<commit_message>
Update group members: add Rafel Romero Hirawanto to presentation, notebook, and README
</commit_message>
<xml_diff>
--- a/PMML_Mini_Project_Presentation.pptx
+++ b/PMML_Mini_Project_Presentation.pptx
@@ -3215,8 +3215,8 @@
         </p:nvSpPr>
         <p:spPr>
           <a:xfrm>
-            <a:off x="914400" y="3017520"/>
-            <a:ext cx="3291840" cy="2468880"/>
+            <a:off x="731520" y="3017520"/>
+            <a:ext cx="2542032" cy="2468880"/>
           </a:xfrm>
           <a:prstGeom prst="roundRect">
             <a:avLst/>
@@ -3245,11 +3245,11 @@
           </a:fontRef>
         </p:style>
         <p:txBody>
-          <a:bodyPr rtlCol="0" anchor="ctr" wrap="square" lIns="182880" rIns="182880" tIns="274320"/>
+          <a:bodyPr rtlCol="0" anchor="ctr" wrap="square" lIns="164592" rIns="164592" tIns="228600"/>
           <a:lstStyle/>
           <a:p>
             <a:pPr algn="ctr">
-              <a:defRPr sz="1000" b="1">
+              <a:defRPr sz="950" b="1">
                 <a:solidFill>
                   <a:srgbClr val="78B4FF"/>
                 </a:solidFill>
@@ -3262,9 +3262,9 @@
           <a:p>
             <a:pPr>
               <a:spcBef>
-                <a:spcPts val="600"/>
-              </a:spcBef>
-              <a:defRPr sz="1600" b="1">
+                <a:spcPts val="500"/>
+              </a:spcBef>
+              <a:defRPr sz="1300" b="1">
                 <a:solidFill>
                   <a:srgbClr val="FFFFFF"/>
                 </a:solidFill>
@@ -3279,7 +3279,7 @@
               <a:spcBef>
                 <a:spcPts val="400"/>
               </a:spcBef>
-              <a:defRPr sz="1300" b="1">
+              <a:defRPr sz="1100" b="1">
                 <a:solidFill>
                   <a:srgbClr val="F5B93C"/>
                 </a:solidFill>
@@ -3292,9 +3292,9 @@
           <a:p>
             <a:pPr>
               <a:spcBef>
-                <a:spcPts val="1000"/>
-              </a:spcBef>
-              <a:defRPr sz="1100">
+                <a:spcPts val="800"/>
+              </a:spcBef>
+              <a:defRPr sz="950">
                 <a:solidFill>
                   <a:srgbClr val="C8D7EB"/>
                 </a:solidFill>
@@ -3318,8 +3318,8 @@
         </p:nvSpPr>
         <p:spPr>
           <a:xfrm>
-            <a:off x="4480560" y="3017520"/>
-            <a:ext cx="3291840" cy="2468880"/>
+            <a:off x="3465576" y="3017520"/>
+            <a:ext cx="2542032" cy="2468880"/>
           </a:xfrm>
           <a:prstGeom prst="roundRect">
             <a:avLst/>
@@ -3348,11 +3348,11 @@
           </a:fontRef>
         </p:style>
         <p:txBody>
-          <a:bodyPr rtlCol="0" anchor="ctr" wrap="square" lIns="182880" rIns="182880" tIns="274320"/>
+          <a:bodyPr rtlCol="0" anchor="ctr" wrap="square" lIns="164592" rIns="164592" tIns="228600"/>
           <a:lstStyle/>
           <a:p>
             <a:pPr algn="ctr">
-              <a:defRPr sz="1000" b="1">
+              <a:defRPr sz="950" b="1">
                 <a:solidFill>
                   <a:srgbClr val="78B4FF"/>
                 </a:solidFill>
@@ -3365,9 +3365,9 @@
           <a:p>
             <a:pPr>
               <a:spcBef>
-                <a:spcPts val="600"/>
-              </a:spcBef>
-              <a:defRPr sz="1600" b="1">
+                <a:spcPts val="500"/>
+              </a:spcBef>
+              <a:defRPr sz="1300" b="1">
                 <a:solidFill>
                   <a:srgbClr val="FFFFFF"/>
                 </a:solidFill>
@@ -3382,7 +3382,7 @@
               <a:spcBef>
                 <a:spcPts val="400"/>
               </a:spcBef>
-              <a:defRPr sz="1300" b="1">
+              <a:defRPr sz="1100" b="1">
                 <a:solidFill>
                   <a:srgbClr val="F5B93C"/>
                 </a:solidFill>
@@ -3395,9 +3395,9 @@
           <a:p>
             <a:pPr>
               <a:spcBef>
-                <a:spcPts val="1000"/>
-              </a:spcBef>
-              <a:defRPr sz="1100">
+                <a:spcPts val="800"/>
+              </a:spcBef>
+              <a:defRPr sz="950">
                 <a:solidFill>
                   <a:srgbClr val="C8D7EB"/>
                 </a:solidFill>
@@ -3421,8 +3421,8 @@
         </p:nvSpPr>
         <p:spPr>
           <a:xfrm>
-            <a:off x="8046720" y="3017520"/>
-            <a:ext cx="3291840" cy="2468880"/>
+            <a:off x="6199632" y="3017520"/>
+            <a:ext cx="2542032" cy="2468880"/>
           </a:xfrm>
           <a:prstGeom prst="roundRect">
             <a:avLst/>
@@ -3451,11 +3451,11 @@
           </a:fontRef>
         </p:style>
         <p:txBody>
-          <a:bodyPr rtlCol="0" anchor="ctr" wrap="square" lIns="182880" rIns="182880" tIns="274320"/>
+          <a:bodyPr rtlCol="0" anchor="ctr" wrap="square" lIns="164592" rIns="164592" tIns="228600"/>
           <a:lstStyle/>
           <a:p>
             <a:pPr algn="ctr">
-              <a:defRPr sz="1000" b="1">
+              <a:defRPr sz="950" b="1">
                 <a:solidFill>
                   <a:srgbClr val="78B4FF"/>
                 </a:solidFill>
@@ -3468,15 +3468,118 @@
           <a:p>
             <a:pPr>
               <a:spcBef>
-                <a:spcPts val="600"/>
-              </a:spcBef>
-              <a:defRPr sz="1600" b="1">
+                <a:spcPts val="500"/>
+              </a:spcBef>
+              <a:defRPr sz="1300" b="1">
                 <a:solidFill>
                   <a:srgbClr val="FFFFFF"/>
                 </a:solidFill>
               </a:defRPr>
             </a:pPr>
             <a:r>
+              <a:t>Rafel Romero Hirawanto</a:t>
+            </a:r>
+          </a:p>
+          <a:p>
+            <a:pPr>
+              <a:spcBef>
+                <a:spcPts val="400"/>
+              </a:spcBef>
+              <a:defRPr sz="1100" b="1">
+                <a:solidFill>
+                  <a:srgbClr val="F5B93C"/>
+                </a:solidFill>
+              </a:defRPr>
+            </a:pPr>
+            <a:r>
+              <a:t>25/573260/PPA/07216</a:t>
+            </a:r>
+          </a:p>
+          <a:p>
+            <a:pPr>
+              <a:spcBef>
+                <a:spcPts val="800"/>
+              </a:spcBef>
+              <a:defRPr sz="950">
+                <a:solidFill>
+                  <a:srgbClr val="C8D7EB"/>
+                </a:solidFill>
+              </a:defRPr>
+            </a:pPr>
+            <a:r>
+              <a:t>Magister Ilmu Komputer</a:t>
+            </a:r>
+            <a:br/>
+            <a:r>
+              <a:t>Universitas Gadjah Mada</a:t>
+            </a:r>
+          </a:p>
+        </p:txBody>
+      </p:sp>
+      <p:sp>
+        <p:nvSpPr>
+          <p:cNvPr id="7" name="Rounded Rectangle 6"/>
+          <p:cNvSpPr/>
+          <p:nvPr/>
+        </p:nvSpPr>
+        <p:spPr>
+          <a:xfrm>
+            <a:off x="8933688" y="3017520"/>
+            <a:ext cx="2542032" cy="2468880"/>
+          </a:xfrm>
+          <a:prstGeom prst="roundRect">
+            <a:avLst/>
+          </a:prstGeom>
+          <a:solidFill>
+            <a:srgbClr val="192D5A"/>
+          </a:solidFill>
+          <a:ln w="19050">
+            <a:solidFill>
+              <a:srgbClr val="3C64A0"/>
+            </a:solidFill>
+          </a:ln>
+        </p:spPr>
+        <p:style>
+          <a:lnRef idx="1">
+            <a:schemeClr val="accent1"/>
+          </a:lnRef>
+          <a:fillRef idx="3">
+            <a:schemeClr val="accent1"/>
+          </a:fillRef>
+          <a:effectRef idx="2">
+            <a:schemeClr val="accent1"/>
+          </a:effectRef>
+          <a:fontRef idx="minor">
+            <a:schemeClr val="lt1"/>
+          </a:fontRef>
+        </p:style>
+        <p:txBody>
+          <a:bodyPr rtlCol="0" anchor="ctr" wrap="square" lIns="164592" rIns="164592" tIns="228600"/>
+          <a:lstStyle/>
+          <a:p>
+            <a:pPr algn="ctr">
+              <a:defRPr sz="950" b="1">
+                <a:solidFill>
+                  <a:srgbClr val="78B4FF"/>
+                </a:solidFill>
+              </a:defRPr>
+            </a:pPr>
+            <a:r>
+              <a:t>ANGGOTA 4</a:t>
+            </a:r>
+          </a:p>
+          <a:p>
+            <a:pPr>
+              <a:spcBef>
+                <a:spcPts val="500"/>
+              </a:spcBef>
+              <a:defRPr sz="1300" b="1">
+                <a:solidFill>
+                  <a:srgbClr val="FFFFFF"/>
+                </a:solidFill>
+              </a:defRPr>
+            </a:pPr>
+            <a:r>
               <a:t>Sidikara Hakim</a:t>
             </a:r>
           </a:p>
@@ -3485,7 +3588,7 @@
               <a:spcBef>
                 <a:spcPts val="400"/>
               </a:spcBef>
-              <a:defRPr sz="1300" b="1">
+              <a:defRPr sz="1100" b="1">
                 <a:solidFill>
                   <a:srgbClr val="F5B93C"/>
                 </a:solidFill>
@@ -3498,9 +3601,9 @@
           <a:p>
             <a:pPr>
               <a:spcBef>
-                <a:spcPts val="1000"/>
-              </a:spcBef>
-              <a:defRPr sz="1100">
+                <a:spcPts val="800"/>
+              </a:spcBef>
+              <a:defRPr sz="950">
                 <a:solidFill>
                   <a:srgbClr val="C8D7EB"/>
                 </a:solidFill>
@@ -3518,7 +3621,7 @@
       </p:sp>
       <p:sp>
         <p:nvSpPr>
-          <p:cNvPr id="7" name="TextBox 6"/>
+          <p:cNvPr id="8" name="TextBox 7"/>
           <p:cNvSpPr txBox="1"/>
           <p:nvPr/>
         </p:nvSpPr>
@@ -5111,7 +5214,7 @@
         <p:spPr>
           <a:xfrm>
             <a:off x="731520" y="1645920"/>
-            <a:ext cx="3474720" cy="4663440"/>
+            <a:ext cx="2542032" cy="4663440"/>
           </a:xfrm>
           <a:prstGeom prst="roundRect">
             <a:avLst/>
@@ -5140,11 +5243,11 @@
           </a:fontRef>
         </p:style>
         <p:txBody>
-          <a:bodyPr rtlCol="0" anchor="ctr" wrap="square" lIns="182880" rIns="182880" tIns="228600"/>
+          <a:bodyPr rtlCol="0" anchor="ctr" wrap="square" lIns="146304" rIns="146304" tIns="182880"/>
           <a:lstStyle/>
           <a:p>
             <a:pPr algn="ctr">
-              <a:defRPr sz="1300" b="1">
+              <a:defRPr sz="1100" b="1">
                 <a:solidFill>
                   <a:srgbClr val="191E28"/>
                 </a:solidFill>
@@ -5156,7 +5259,7 @@
           </a:p>
           <a:p>
             <a:pPr>
-              <a:defRPr sz="1000" b="1">
+              <a:defRPr sz="950" b="1">
                 <a:solidFill>
                   <a:srgbClr val="646E7D"/>
                 </a:solidFill>
@@ -5169,79 +5272,79 @@
           <a:p>
             <a:pPr>
               <a:spcBef>
+                <a:spcPts val="600"/>
+              </a:spcBef>
+              <a:spcAft>
                 <a:spcPts val="800"/>
-              </a:spcBef>
-              <a:spcAft>
-                <a:spcPts val="1000"/>
               </a:spcAft>
-              <a:defRPr sz="1000" b="1">
+              <a:defRPr sz="900" b="1">
                 <a:solidFill>
                   <a:srgbClr val="1E5AA0"/>
                 </a:solidFill>
               </a:defRPr>
             </a:pPr>
             <a:r>
-              <a:t>DATA PREPROCESSING &amp; VALIDATION SCHEME</a:t>
-            </a:r>
-          </a:p>
-          <a:p>
-            <a:pPr>
-              <a:spcBef>
-                <a:spcPts val="400"/>
-              </a:spcBef>
-              <a:defRPr sz="1000">
+              <a:t>DATA PREPROCESSING &amp; VALIDATION</a:t>
+            </a:r>
+          </a:p>
+          <a:p>
+            <a:pPr>
+              <a:spcBef>
+                <a:spcPts val="300"/>
+              </a:spcBef>
+              <a:defRPr sz="850">
                 <a:solidFill>
                   <a:srgbClr val="191E28"/>
                 </a:solidFill>
               </a:defRPr>
             </a:pPr>
             <a:r>
-              <a:t>• Eksplorasi dan validasi secondary dataset UCI Breast Cancer Wisconsin.</a:t>
-            </a:r>
-          </a:p>
-          <a:p>
-            <a:pPr>
-              <a:spcBef>
-                <a:spcPts val="400"/>
-              </a:spcBef>
-              <a:defRPr sz="1000">
+              <a:t>• Eksplorasi dataset sekunder UCI Breast Cancer Wisconsin (569 sampel, 30 fitur).</a:t>
+            </a:r>
+          </a:p>
+          <a:p>
+            <a:pPr>
+              <a:spcBef>
+                <a:spcPts val="300"/>
+              </a:spcBef>
+              <a:defRPr sz="850">
                 <a:solidFill>
                   <a:srgbClr val="191E28"/>
                 </a:solidFill>
               </a:defRPr>
             </a:pPr>
             <a:r>
-              <a:t>• Desain skema Stratified 5-Fold Cross-Validation dan Hold-out Test split (80:20).</a:t>
-            </a:r>
-          </a:p>
-          <a:p>
-            <a:pPr>
-              <a:spcBef>
-                <a:spcPts val="400"/>
-              </a:spcBef>
-              <a:defRPr sz="1000">
+              <a:t>• Desain skema Stratified 5-Fold Cross-Validation dan Train-Test split (80:20).</a:t>
+            </a:r>
+          </a:p>
+          <a:p>
+            <a:pPr>
+              <a:spcBef>
+                <a:spcPts val="300"/>
+              </a:spcBef>
+              <a:defRPr sz="850">
                 <a:solidFill>
                   <a:srgbClr val="191E28"/>
                 </a:solidFill>
               </a:defRPr>
             </a:pPr>
             <a:r>
-              <a:t>• Implementasi StandardScaler strictly pada training fold untuk pencegahan data leakage.</a:t>
-            </a:r>
-          </a:p>
-          <a:p>
-            <a:pPr>
-              <a:spcBef>
-                <a:spcPts val="400"/>
-              </a:spcBef>
-              <a:defRPr sz="1000">
+              <a:t>• Standardisasi fitur (StandardScaler) strictly pada train fold anti data leakage.</a:t>
+            </a:r>
+          </a:p>
+          <a:p>
+            <a:pPr>
+              <a:spcBef>
+                <a:spcPts val="300"/>
+              </a:spcBef>
+              <a:defRPr sz="850">
                 <a:solidFill>
                   <a:srgbClr val="191E28"/>
                 </a:solidFill>
               </a:defRPr>
             </a:pPr>
             <a:r>
-              <a:t>• Pembangunan dan evaluasi Model 1 (Baseline Shallow MLP) sebagai standar komparasi.</a:t>
+              <a:t>• Implementasi arsitektur Model 1 (Baseline Shallow MLP) sebagai standar komparasi.</a:t>
             </a:r>
           </a:p>
         </p:txBody>
@@ -5254,8 +5357,8 @@
         </p:nvSpPr>
         <p:spPr>
           <a:xfrm>
-            <a:off x="4370832" y="1645920"/>
-            <a:ext cx="3474720" cy="4663440"/>
+            <a:off x="3465576" y="1645920"/>
+            <a:ext cx="2542032" cy="4663440"/>
           </a:xfrm>
           <a:prstGeom prst="roundRect">
             <a:avLst/>
@@ -5284,11 +5387,11 @@
           </a:fontRef>
         </p:style>
         <p:txBody>
-          <a:bodyPr rtlCol="0" anchor="ctr" wrap="square" lIns="182880" rIns="182880" tIns="228600"/>
+          <a:bodyPr rtlCol="0" anchor="ctr" wrap="square" lIns="146304" rIns="146304" tIns="182880"/>
           <a:lstStyle/>
           <a:p>
             <a:pPr algn="ctr">
-              <a:defRPr sz="1300" b="1">
+              <a:defRPr sz="1100" b="1">
                 <a:solidFill>
                   <a:srgbClr val="191E28"/>
                 </a:solidFill>
@@ -5300,7 +5403,7 @@
           </a:p>
           <a:p>
             <a:pPr>
-              <a:defRPr sz="1000" b="1">
+              <a:defRPr sz="950" b="1">
                 <a:solidFill>
                   <a:srgbClr val="646E7D"/>
                 </a:solidFill>
@@ -5313,79 +5416,79 @@
           <a:p>
             <a:pPr>
               <a:spcBef>
+                <a:spcPts val="600"/>
+              </a:spcBef>
+              <a:spcAft>
                 <a:spcPts val="800"/>
-              </a:spcBef>
-              <a:spcAft>
-                <a:spcPts val="1000"/>
               </a:spcAft>
-              <a:defRPr sz="1000" b="1">
+              <a:defRPr sz="900" b="1">
                 <a:solidFill>
                   <a:srgbClr val="148250"/>
                 </a:solidFill>
               </a:defRPr>
             </a:pPr>
             <a:r>
-              <a:t>DEEP LEARNING ARCHITECTURES &amp; REGULARIZATION</a:t>
-            </a:r>
-          </a:p>
-          <a:p>
-            <a:pPr>
-              <a:spcBef>
-                <a:spcPts val="400"/>
-              </a:spcBef>
-              <a:defRPr sz="1000">
+              <a:t>DEEP MLP &amp; OPTIMIZER TUNING</a:t>
+            </a:r>
+          </a:p>
+          <a:p>
+            <a:pPr>
+              <a:spcBef>
+                <a:spcPts val="300"/>
+              </a:spcBef>
+              <a:defRPr sz="850">
                 <a:solidFill>
                   <a:srgbClr val="191E28"/>
                 </a:solidFill>
               </a:defRPr>
             </a:pPr>
             <a:r>
-              <a:t>• Perancangan Deep MLP (3 hidden layers) untuk ekstraksi representasi fitur mendalam.</a:t>
-            </a:r>
-          </a:p>
-          <a:p>
-            <a:pPr>
-              <a:spcBef>
-                <a:spcPts val="400"/>
-              </a:spcBef>
-              <a:defRPr sz="1000">
+              <a:t>• Perancangan Deep MLP (3 hidden layers: 128-64-32) untuk representasi fitur.</a:t>
+            </a:r>
+          </a:p>
+          <a:p>
+            <a:pPr>
+              <a:spcBef>
+                <a:spcPts val="300"/>
+              </a:spcBef>
+              <a:defRPr sz="850">
                 <a:solidFill>
                   <a:srgbClr val="191E28"/>
                 </a:solidFill>
               </a:defRPr>
             </a:pPr>
             <a:r>
-              <a:t>• Desain Regularized Deep MLP dengan Batch Normalization, Dropout (0.3-0.1), &amp; L2 Decay.</a:t>
-            </a:r>
-          </a:p>
-          <a:p>
-            <a:pPr>
-              <a:spcBef>
-                <a:spcPts val="400"/>
-              </a:spcBef>
-              <a:defRPr sz="1000">
+              <a:t>• Eksperimen komparasi optimizers (Adam, RMSprop, SGD Nesterov Momentum).</a:t>
+            </a:r>
+          </a:p>
+          <a:p>
+            <a:pPr>
+              <a:spcBef>
+                <a:spcPts val="300"/>
+              </a:spcBef>
+              <a:defRPr sz="850">
                 <a:solidFill>
                   <a:srgbClr val="191E28"/>
                 </a:solidFill>
               </a:defRPr>
             </a:pPr>
             <a:r>
-              <a:t>• Implementasi arsitektur modern Deep Residual MLP (Res-MLP) dengan Skip Connections &amp; GELU.</a:t>
-            </a:r>
-          </a:p>
-          <a:p>
-            <a:pPr>
-              <a:spcBef>
-                <a:spcPts val="400"/>
-              </a:spcBef>
-              <a:defRPr sz="1000">
+              <a:t>• Analisis sensitivitas learning rate (0.01, 0.001, 0.0001) terhadap konvergensi.</a:t>
+            </a:r>
+          </a:p>
+          <a:p>
+            <a:pPr>
+              <a:spcBef>
+                <a:spcPts val="300"/>
+              </a:spcBef>
+              <a:defRPr sz="850">
                 <a:solidFill>
                   <a:srgbClr val="191E28"/>
                 </a:solidFill>
               </a:defRPr>
             </a:pPr>
             <a:r>
-              <a:t>• Eksperimen tuning optimizers (Adam, RMSprop, SGD) &amp; dynamic learning rate schedulers.</a:t>
+              <a:t>• Penerapan dynamic learning rate scheduler (ReduceLROnPlateau) &amp; early stopping.</a:t>
             </a:r>
           </a:p>
         </p:txBody>
@@ -5398,8 +5501,8 @@
         </p:nvSpPr>
         <p:spPr>
           <a:xfrm>
-            <a:off x="8010144" y="1645920"/>
-            <a:ext cx="3474720" cy="4663440"/>
+            <a:off x="6199632" y="1645920"/>
+            <a:ext cx="2542032" cy="4663440"/>
           </a:xfrm>
           <a:prstGeom prst="roundRect">
             <a:avLst/>
@@ -5428,23 +5531,167 @@
           </a:fontRef>
         </p:style>
         <p:txBody>
-          <a:bodyPr rtlCol="0" anchor="ctr" wrap="square" lIns="182880" rIns="182880" tIns="228600"/>
+          <a:bodyPr rtlCol="0" anchor="ctr" wrap="square" lIns="146304" rIns="146304" tIns="182880"/>
           <a:lstStyle/>
           <a:p>
             <a:pPr algn="ctr">
-              <a:defRPr sz="1300" b="1">
+              <a:defRPr sz="1100" b="1">
                 <a:solidFill>
                   <a:srgbClr val="191E28"/>
                 </a:solidFill>
               </a:defRPr>
             </a:pPr>
             <a:r>
+              <a:t>Rafel Romero Hirawanto</a:t>
+            </a:r>
+          </a:p>
+          <a:p>
+            <a:pPr>
+              <a:defRPr sz="950" b="1">
+                <a:solidFill>
+                  <a:srgbClr val="646E7D"/>
+                </a:solidFill>
+              </a:defRPr>
+            </a:pPr>
+            <a:r>
+              <a:t>25/573260/PPA/07216</a:t>
+            </a:r>
+          </a:p>
+          <a:p>
+            <a:pPr>
+              <a:spcBef>
+                <a:spcPts val="600"/>
+              </a:spcBef>
+              <a:spcAft>
+                <a:spcPts val="800"/>
+              </a:spcAft>
+              <a:defRPr sz="900" b="1">
+                <a:solidFill>
+                  <a:srgbClr val="DC6E14"/>
+                </a:solidFill>
+              </a:defRPr>
+            </a:pPr>
+            <a:r>
+              <a:t>REGULARIZATION &amp; RESIDUAL NETWORK</a:t>
+            </a:r>
+          </a:p>
+          <a:p>
+            <a:pPr>
+              <a:spcBef>
+                <a:spcPts val="300"/>
+              </a:spcBef>
+              <a:defRPr sz="850">
+                <a:solidFill>
+                  <a:srgbClr val="191E28"/>
+                </a:solidFill>
+              </a:defRPr>
+            </a:pPr>
+            <a:r>
+              <a:t>• Desain Regularized Deep MLP dengan Batch Normalization, Dropout, &amp; L2 Decay.</a:t>
+            </a:r>
+          </a:p>
+          <a:p>
+            <a:pPr>
+              <a:spcBef>
+                <a:spcPts val="300"/>
+              </a:spcBef>
+              <a:defRPr sz="850">
+                <a:solidFill>
+                  <a:srgbClr val="191E28"/>
+                </a:solidFill>
+              </a:defRPr>
+            </a:pPr>
+            <a:r>
+              <a:t>• Implementasi arsitektur mutakhir Deep Residual MLP (Res-MLP) dengan skip connection.</a:t>
+            </a:r>
+          </a:p>
+          <a:p>
+            <a:pPr>
+              <a:spcBef>
+                <a:spcPts val="300"/>
+              </a:spcBef>
+              <a:defRPr sz="850">
+                <a:solidFill>
+                  <a:srgbClr val="191E28"/>
+                </a:solidFill>
+              </a:defRPr>
+            </a:pPr>
+            <a:r>
+              <a:t>• Integrasi fungsi aktivasi non-linear GELU dan Layer Normalization pada blok residual.</a:t>
+            </a:r>
+          </a:p>
+          <a:p>
+            <a:pPr>
+              <a:spcBef>
+                <a:spcPts val="300"/>
+              </a:spcBef>
+              <a:defRPr sz="850">
+                <a:solidFill>
+                  <a:srgbClr val="191E28"/>
+                </a:solidFill>
+              </a:defRPr>
+            </a:pPr>
+            <a:r>
+              <a:t>• Analisis mitigasi overfitting dan reduksi internal covariate shift antar-layer.</a:t>
+            </a:r>
+          </a:p>
+        </p:txBody>
+      </p:sp>
+      <p:sp>
+        <p:nvSpPr>
+          <p:cNvPr id="8" name="Rounded Rectangle 7"/>
+          <p:cNvSpPr/>
+          <p:nvPr/>
+        </p:nvSpPr>
+        <p:spPr>
+          <a:xfrm>
+            <a:off x="8933688" y="1645920"/>
+            <a:ext cx="2542032" cy="4663440"/>
+          </a:xfrm>
+          <a:prstGeom prst="roundRect">
+            <a:avLst/>
+          </a:prstGeom>
+          <a:solidFill>
+            <a:srgbClr val="FFFFFF"/>
+          </a:solidFill>
+          <a:ln w="12700">
+            <a:solidFill>
+              <a:srgbClr val="DCE1EB"/>
+            </a:solidFill>
+          </a:ln>
+        </p:spPr>
+        <p:style>
+          <a:lnRef idx="1">
+            <a:schemeClr val="accent1"/>
+          </a:lnRef>
+          <a:fillRef idx="3">
+            <a:schemeClr val="accent1"/>
+          </a:fillRef>
+          <a:effectRef idx="2">
+            <a:schemeClr val="accent1"/>
+          </a:effectRef>
+          <a:fontRef idx="minor">
+            <a:schemeClr val="lt1"/>
+          </a:fontRef>
+        </p:style>
+        <p:txBody>
+          <a:bodyPr rtlCol="0" anchor="ctr" wrap="square" lIns="146304" rIns="146304" tIns="182880"/>
+          <a:lstStyle/>
+          <a:p>
+            <a:pPr algn="ctr">
+              <a:defRPr sz="1100" b="1">
+                <a:solidFill>
+                  <a:srgbClr val="191E28"/>
+                </a:solidFill>
+              </a:defRPr>
+            </a:pPr>
+            <a:r>
               <a:t>Sidikara Hakim</a:t>
             </a:r>
           </a:p>
           <a:p>
             <a:pPr>
-              <a:defRPr sz="1000" b="1">
+              <a:defRPr sz="950" b="1">
                 <a:solidFill>
                   <a:srgbClr val="646E7D"/>
                 </a:solidFill>
@@ -5457,42 +5704,42 @@
           <a:p>
             <a:pPr>
               <a:spcBef>
+                <a:spcPts val="600"/>
+              </a:spcBef>
+              <a:spcAft>
                 <a:spcPts val="800"/>
-              </a:spcBef>
-              <a:spcAft>
-                <a:spcPts val="1000"/>
               </a:spcAft>
-              <a:defRPr sz="1000" b="1">
+              <a:defRPr sz="900" b="1">
                 <a:solidFill>
                   <a:srgbClr val="8C3296"/>
                 </a:solidFill>
               </a:defRPr>
             </a:pPr>
             <a:r>
-              <a:t>COMPREHENSIVE EXPERIMENTS &amp; CLINICAL EVALUATION</a:t>
-            </a:r>
-          </a:p>
-          <a:p>
-            <a:pPr>
-              <a:spcBef>
-                <a:spcPts val="400"/>
-              </a:spcBef>
-              <a:defRPr sz="1000">
+              <a:t>CLINICAL EVALUATION &amp; PRESENTATION</a:t>
+            </a:r>
+          </a:p>
+          <a:p>
+            <a:pPr>
+              <a:spcBef>
+                <a:spcPts val="300"/>
+              </a:spcBef>
+              <a:defRPr sz="850">
                 <a:solidFill>
                   <a:srgbClr val="191E28"/>
                 </a:solidFill>
               </a:defRPr>
             </a:pPr>
             <a:r>
-              <a:t>• Evaluasi metrik diagnostik komprehensif (Accuracy, Precision, Recall, Specificity, F1, ROC-AUC).</a:t>
-            </a:r>
-          </a:p>
-          <a:p>
-            <a:pPr>
-              <a:spcBef>
-                <a:spcPts val="400"/>
-              </a:spcBef>
-              <a:defRPr sz="1000">
+              <a:t>• Evaluasi metrik diagnostik komprehensif (Accuracy, Recall, Specificity, F1, ROC-AUC).</a:t>
+            </a:r>
+          </a:p>
+          <a:p>
+            <a:pPr>
+              <a:spcBef>
+                <a:spcPts val="300"/>
+              </a:spcBef>
+              <a:defRPr sz="850">
                 <a:solidFill>
                   <a:srgbClr val="191E28"/>
                 </a:solidFill>
@@ -5505,31 +5752,31 @@
           <a:p>
             <a:pPr>
               <a:spcBef>
-                <a:spcPts val="400"/>
-              </a:spcBef>
-              <a:defRPr sz="1000">
+                <a:spcPts val="300"/>
+              </a:spcBef>
+              <a:defRPr sz="850">
                 <a:solidFill>
                   <a:srgbClr val="191E28"/>
                 </a:solidFill>
               </a:defRPr>
             </a:pPr>
             <a:r>
-              <a:t>• Generasi visualisasi saintifik resolusi tinggi (Learning Curves, Confusion Matrix, ROC curves).</a:t>
-            </a:r>
-          </a:p>
-          <a:p>
-            <a:pPr>
-              <a:spcBef>
-                <a:spcPts val="400"/>
-              </a:spcBef>
-              <a:defRPr sz="1000">
+              <a:t>• Generasi visualisasi saintifik resolusi tinggi (Learning Curves, Confusion Matrix, ROC).</a:t>
+            </a:r>
+          </a:p>
+          <a:p>
+            <a:pPr>
+              <a:spcBef>
+                <a:spcPts val="300"/>
+              </a:spcBef>
+              <a:defRPr sz="850">
                 <a:solidFill>
                   <a:srgbClr val="191E28"/>
                 </a:solidFill>
               </a:defRPr>
             </a:pPr>
             <a:r>
-              <a:t>• Penyusunan slide presentasi profesional, struktur repositori kode, dan dokumentasi teknis.</a:t>
+              <a:t>• Penyusunan slide presentasi profesional 12 halaman dan dokumentasi repositori.</a:t>
             </a:r>
           </a:p>
         </p:txBody>

</xml_diff>

<commit_message>
Add 12-page presentation report PDF: Laporan_Presentasi_PMML.pdf
</commit_message>
<xml_diff>
--- a/PMML_Mini_Project_Presentation.pptx
+++ b/PMML_Mini_Project_Presentation.pptx
@@ -5,20 +5,20 @@
     <p:sldMasterId id="2147483648" r:id="rId1"/>
   </p:sldMasterIdLst>
   <p:sldIdLst>
-    <p:sldId id="256" r:id="rId7"/>
-    <p:sldId id="257" r:id="rId8"/>
-    <p:sldId id="258" r:id="rId9"/>
-    <p:sldId id="259" r:id="rId10"/>
-    <p:sldId id="260" r:id="rId11"/>
-    <p:sldId id="261" r:id="rId12"/>
-    <p:sldId id="262" r:id="rId13"/>
-    <p:sldId id="263" r:id="rId14"/>
-    <p:sldId id="264" r:id="rId15"/>
-    <p:sldId id="265" r:id="rId16"/>
-    <p:sldId id="266" r:id="rId17"/>
-    <p:sldId id="267" r:id="rId18"/>
+    <p:sldId id="256" r:id="rId2"/>
+    <p:sldId id="257" r:id="rId3"/>
+    <p:sldId id="258" r:id="rId4"/>
+    <p:sldId id="259" r:id="rId5"/>
+    <p:sldId id="260" r:id="rId6"/>
+    <p:sldId id="261" r:id="rId7"/>
+    <p:sldId id="262" r:id="rId8"/>
+    <p:sldId id="263" r:id="rId9"/>
+    <p:sldId id="264" r:id="rId10"/>
+    <p:sldId id="265" r:id="rId11"/>
+    <p:sldId id="266" r:id="rId12"/>
+    <p:sldId id="267" r:id="rId13"/>
   </p:sldIdLst>
-  <p:sldSz cx="12191695" cy="6858000" type="screen4x3"/>
+  <p:sldSz cx="12192000" cy="6858000"/>
   <p:notesSz cx="6858000" cy="9144000"/>
   <p:defaultTextStyle>
     <a:defPPr>
@@ -115,6 +115,22 @@
       </a:defRPr>
     </a:lvl9pPr>
   </p:defaultTextStyle>
+  <p:extLst>
+    <p:ext uri="{EFAFB233-063F-42B5-8137-9DF3F51BA10A}">
+      <p15:sldGuideLst xmlns:p15="http://schemas.microsoft.com/office/powerpoint/2012/main">
+        <p15:guide id="1" orient="horz" pos="2160">
+          <p15:clr>
+            <a:srgbClr val="A4A3A4"/>
+          </p15:clr>
+        </p15:guide>
+        <p15:guide id="2" pos="2880">
+          <p15:clr>
+            <a:srgbClr val="A4A3A4"/>
+          </p15:clr>
+        </p15:guide>
+      </p15:sldGuideLst>
+    </p:ext>
+  </p:extLst>
 </p:presentation>
 </file>
 
@@ -156,10 +172,9 @@
           <a:lstStyle/>
           <a:p>
             <a:r>
-              <a:rPr lang="en-US" smtClean="0"/>
+              <a:rPr lang="en-US"/>
               <a:t>Click to edit Master title style</a:t>
             </a:r>
-            <a:endParaRPr lang="en-US"/>
           </a:p>
         </p:txBody>
       </p:sp>
@@ -275,10 +290,9 @@
           </a:lstStyle>
           <a:p>
             <a:r>
-              <a:rPr lang="en-US" smtClean="0"/>
+              <a:rPr lang="en-US"/>
               <a:t>Click to edit Master subtitle style</a:t>
             </a:r>
-            <a:endParaRPr lang="en-US"/>
           </a:p>
         </p:txBody>
       </p:sp>
@@ -299,7 +313,7 @@
           <a:p>
             <a:fld id="{5BCAD085-E8A6-8845-BD4E-CB4CCA059FC4}" type="datetimeFigureOut">
               <a:rPr lang="en-US" smtClean="0"/>
-              <a:t>1/27/13</a:t>
+              <a:t>10/15/2026</a:t>
             </a:fld>
             <a:endParaRPr lang="en-US"/>
           </a:p>
@@ -393,10 +407,9 @@
           <a:lstStyle/>
           <a:p>
             <a:r>
-              <a:rPr lang="en-US" smtClean="0"/>
+              <a:rPr lang="en-US"/>
               <a:t>Click to edit Master title style</a:t>
             </a:r>
-            <a:endParaRPr lang="en-US"/>
           </a:p>
         </p:txBody>
       </p:sp>
@@ -417,38 +430,37 @@
           <a:p>
             <a:pPr lvl="0"/>
             <a:r>
-              <a:rPr lang="en-US" smtClean="0"/>
+              <a:rPr lang="en-US"/>
               <a:t>Click to edit Master text styles</a:t>
             </a:r>
           </a:p>
           <a:p>
             <a:pPr lvl="1"/>
             <a:r>
-              <a:rPr lang="en-US" smtClean="0"/>
+              <a:rPr lang="en-US"/>
               <a:t>Second level</a:t>
             </a:r>
           </a:p>
           <a:p>
             <a:pPr lvl="2"/>
             <a:r>
-              <a:rPr lang="en-US" smtClean="0"/>
+              <a:rPr lang="en-US"/>
               <a:t>Third level</a:t>
             </a:r>
           </a:p>
           <a:p>
             <a:pPr lvl="3"/>
             <a:r>
-              <a:rPr lang="en-US" smtClean="0"/>
+              <a:rPr lang="en-US"/>
               <a:t>Fourth level</a:t>
             </a:r>
           </a:p>
           <a:p>
             <a:pPr lvl="4"/>
             <a:r>
-              <a:rPr lang="en-US" smtClean="0"/>
+              <a:rPr lang="en-US"/>
               <a:t>Fifth level</a:t>
             </a:r>
-            <a:endParaRPr lang="en-US"/>
           </a:p>
         </p:txBody>
       </p:sp>
@@ -469,7 +481,7 @@
           <a:p>
             <a:fld id="{5BCAD085-E8A6-8845-BD4E-CB4CCA059FC4}" type="datetimeFigureOut">
               <a:rPr lang="en-US" smtClean="0"/>
-              <a:t>1/27/13</a:t>
+              <a:t>10/15/2026</a:t>
             </a:fld>
             <a:endParaRPr lang="en-US"/>
           </a:p>
@@ -568,10 +580,9 @@
           <a:lstStyle/>
           <a:p>
             <a:r>
-              <a:rPr lang="en-US" smtClean="0"/>
+              <a:rPr lang="en-US"/>
               <a:t>Click to edit Master title style</a:t>
             </a:r>
-            <a:endParaRPr lang="en-US"/>
           </a:p>
         </p:txBody>
       </p:sp>
@@ -597,38 +608,37 @@
           <a:p>
             <a:pPr lvl="0"/>
             <a:r>
-              <a:rPr lang="en-US" smtClean="0"/>
+              <a:rPr lang="en-US"/>
               <a:t>Click to edit Master text styles</a:t>
             </a:r>
           </a:p>
           <a:p>
             <a:pPr lvl="1"/>
             <a:r>
-              <a:rPr lang="en-US" smtClean="0"/>
+              <a:rPr lang="en-US"/>
               <a:t>Second level</a:t>
             </a:r>
           </a:p>
           <a:p>
             <a:pPr lvl="2"/>
             <a:r>
-              <a:rPr lang="en-US" smtClean="0"/>
+              <a:rPr lang="en-US"/>
               <a:t>Third level</a:t>
             </a:r>
           </a:p>
           <a:p>
             <a:pPr lvl="3"/>
             <a:r>
-              <a:rPr lang="en-US" smtClean="0"/>
+              <a:rPr lang="en-US"/>
               <a:t>Fourth level</a:t>
             </a:r>
           </a:p>
           <a:p>
             <a:pPr lvl="4"/>
             <a:r>
-              <a:rPr lang="en-US" smtClean="0"/>
+              <a:rPr lang="en-US"/>
               <a:t>Fifth level</a:t>
             </a:r>
-            <a:endParaRPr lang="en-US"/>
           </a:p>
         </p:txBody>
       </p:sp>
@@ -649,7 +659,7 @@
           <a:p>
             <a:fld id="{5BCAD085-E8A6-8845-BD4E-CB4CCA059FC4}" type="datetimeFigureOut">
               <a:rPr lang="en-US" smtClean="0"/>
-              <a:t>1/27/13</a:t>
+              <a:t>10/15/2026</a:t>
             </a:fld>
             <a:endParaRPr lang="en-US"/>
           </a:p>
@@ -743,10 +753,9 @@
           <a:lstStyle/>
           <a:p>
             <a:r>
-              <a:rPr lang="en-US" smtClean="0"/>
+              <a:rPr lang="en-US"/>
               <a:t>Click to edit Master title style</a:t>
             </a:r>
-            <a:endParaRPr lang="en-US"/>
           </a:p>
         </p:txBody>
       </p:sp>
@@ -767,38 +776,37 @@
           <a:p>
             <a:pPr lvl="0"/>
             <a:r>
-              <a:rPr lang="en-US" smtClean="0"/>
+              <a:rPr lang="en-US"/>
               <a:t>Click to edit Master text styles</a:t>
             </a:r>
           </a:p>
           <a:p>
             <a:pPr lvl="1"/>
             <a:r>
-              <a:rPr lang="en-US" smtClean="0"/>
+              <a:rPr lang="en-US"/>
               <a:t>Second level</a:t>
             </a:r>
           </a:p>
           <a:p>
             <a:pPr lvl="2"/>
             <a:r>
-              <a:rPr lang="en-US" smtClean="0"/>
+              <a:rPr lang="en-US"/>
               <a:t>Third level</a:t>
             </a:r>
           </a:p>
           <a:p>
             <a:pPr lvl="3"/>
             <a:r>
-              <a:rPr lang="en-US" smtClean="0"/>
+              <a:rPr lang="en-US"/>
               <a:t>Fourth level</a:t>
             </a:r>
           </a:p>
           <a:p>
             <a:pPr lvl="4"/>
             <a:r>
-              <a:rPr lang="en-US" smtClean="0"/>
+              <a:rPr lang="en-US"/>
               <a:t>Fifth level</a:t>
             </a:r>
-            <a:endParaRPr lang="en-US"/>
           </a:p>
         </p:txBody>
       </p:sp>
@@ -819,7 +827,7 @@
           <a:p>
             <a:fld id="{5BCAD085-E8A6-8845-BD4E-CB4CCA059FC4}" type="datetimeFigureOut">
               <a:rPr lang="en-US" smtClean="0"/>
-              <a:t>1/27/13</a:t>
+              <a:t>10/15/2026</a:t>
             </a:fld>
             <a:endParaRPr lang="en-US"/>
           </a:p>
@@ -922,10 +930,9 @@
           </a:lstStyle>
           <a:p>
             <a:r>
-              <a:rPr lang="en-US" smtClean="0"/>
+              <a:rPr lang="en-US"/>
               <a:t>Click to edit Master title style</a:t>
             </a:r>
-            <a:endParaRPr lang="en-US"/>
           </a:p>
         </p:txBody>
       </p:sp>
@@ -1042,7 +1049,7 @@
           <a:p>
             <a:pPr lvl="0"/>
             <a:r>
-              <a:rPr lang="en-US" smtClean="0"/>
+              <a:rPr lang="en-US"/>
               <a:t>Click to edit Master text styles</a:t>
             </a:r>
           </a:p>
@@ -1065,7 +1072,7 @@
           <a:p>
             <a:fld id="{5BCAD085-E8A6-8845-BD4E-CB4CCA059FC4}" type="datetimeFigureOut">
               <a:rPr lang="en-US" smtClean="0"/>
-              <a:t>1/27/13</a:t>
+              <a:t>10/15/2026</a:t>
             </a:fld>
             <a:endParaRPr lang="en-US"/>
           </a:p>
@@ -1159,10 +1166,9 @@
           <a:lstStyle/>
           <a:p>
             <a:r>
-              <a:rPr lang="en-US" smtClean="0"/>
+              <a:rPr lang="en-US"/>
               <a:t>Click to edit Master title style</a:t>
             </a:r>
-            <a:endParaRPr lang="en-US"/>
           </a:p>
         </p:txBody>
       </p:sp>
@@ -1216,38 +1222,37 @@
           <a:p>
             <a:pPr lvl="0"/>
             <a:r>
-              <a:rPr lang="en-US" smtClean="0"/>
+              <a:rPr lang="en-US"/>
               <a:t>Click to edit Master text styles</a:t>
             </a:r>
           </a:p>
           <a:p>
             <a:pPr lvl="1"/>
             <a:r>
-              <a:rPr lang="en-US" smtClean="0"/>
+              <a:rPr lang="en-US"/>
               <a:t>Second level</a:t>
             </a:r>
           </a:p>
           <a:p>
             <a:pPr lvl="2"/>
             <a:r>
-              <a:rPr lang="en-US" smtClean="0"/>
+              <a:rPr lang="en-US"/>
               <a:t>Third level</a:t>
             </a:r>
           </a:p>
           <a:p>
             <a:pPr lvl="3"/>
             <a:r>
-              <a:rPr lang="en-US" smtClean="0"/>
+              <a:rPr lang="en-US"/>
               <a:t>Fourth level</a:t>
             </a:r>
           </a:p>
           <a:p>
             <a:pPr lvl="4"/>
             <a:r>
-              <a:rPr lang="en-US" smtClean="0"/>
+              <a:rPr lang="en-US"/>
               <a:t>Fifth level</a:t>
             </a:r>
-            <a:endParaRPr lang="en-US"/>
           </a:p>
         </p:txBody>
       </p:sp>
@@ -1301,38 +1306,37 @@
           <a:p>
             <a:pPr lvl="0"/>
             <a:r>
-              <a:rPr lang="en-US" smtClean="0"/>
+              <a:rPr lang="en-US"/>
               <a:t>Click to edit Master text styles</a:t>
             </a:r>
           </a:p>
           <a:p>
             <a:pPr lvl="1"/>
             <a:r>
-              <a:rPr lang="en-US" smtClean="0"/>
+              <a:rPr lang="en-US"/>
               <a:t>Second level</a:t>
             </a:r>
           </a:p>
           <a:p>
             <a:pPr lvl="2"/>
             <a:r>
-              <a:rPr lang="en-US" smtClean="0"/>
+              <a:rPr lang="en-US"/>
               <a:t>Third level</a:t>
             </a:r>
           </a:p>
           <a:p>
             <a:pPr lvl="3"/>
             <a:r>
-              <a:rPr lang="en-US" smtClean="0"/>
+              <a:rPr lang="en-US"/>
               <a:t>Fourth level</a:t>
             </a:r>
           </a:p>
           <a:p>
             <a:pPr lvl="4"/>
             <a:r>
-              <a:rPr lang="en-US" smtClean="0"/>
+              <a:rPr lang="en-US"/>
               <a:t>Fifth level</a:t>
             </a:r>
-            <a:endParaRPr lang="en-US"/>
           </a:p>
         </p:txBody>
       </p:sp>
@@ -1353,7 +1357,7 @@
           <a:p>
             <a:fld id="{5BCAD085-E8A6-8845-BD4E-CB4CCA059FC4}" type="datetimeFigureOut">
               <a:rPr lang="en-US" smtClean="0"/>
-              <a:t>1/27/13</a:t>
+              <a:t>10/15/2026</a:t>
             </a:fld>
             <a:endParaRPr lang="en-US"/>
           </a:p>
@@ -1451,10 +1455,9 @@
           </a:lstStyle>
           <a:p>
             <a:r>
-              <a:rPr lang="en-US" smtClean="0"/>
+              <a:rPr lang="en-US"/>
               <a:t>Click to edit Master title style</a:t>
             </a:r>
-            <a:endParaRPr lang="en-US"/>
           </a:p>
         </p:txBody>
       </p:sp>
@@ -1517,7 +1520,7 @@
           <a:p>
             <a:pPr lvl="0"/>
             <a:r>
-              <a:rPr lang="en-US" smtClean="0"/>
+              <a:rPr lang="en-US"/>
               <a:t>Click to edit Master text styles</a:t>
             </a:r>
           </a:p>
@@ -1573,38 +1576,37 @@
           <a:p>
             <a:pPr lvl="0"/>
             <a:r>
-              <a:rPr lang="en-US" smtClean="0"/>
+              <a:rPr lang="en-US"/>
               <a:t>Click to edit Master text styles</a:t>
             </a:r>
           </a:p>
           <a:p>
             <a:pPr lvl="1"/>
             <a:r>
-              <a:rPr lang="en-US" smtClean="0"/>
+              <a:rPr lang="en-US"/>
               <a:t>Second level</a:t>
             </a:r>
           </a:p>
           <a:p>
             <a:pPr lvl="2"/>
             <a:r>
-              <a:rPr lang="en-US" smtClean="0"/>
+              <a:rPr lang="en-US"/>
               <a:t>Third level</a:t>
             </a:r>
           </a:p>
           <a:p>
             <a:pPr lvl="3"/>
             <a:r>
-              <a:rPr lang="en-US" smtClean="0"/>
+              <a:rPr lang="en-US"/>
               <a:t>Fourth level</a:t>
             </a:r>
           </a:p>
           <a:p>
             <a:pPr lvl="4"/>
             <a:r>
-              <a:rPr lang="en-US" smtClean="0"/>
+              <a:rPr lang="en-US"/>
               <a:t>Fifth level</a:t>
             </a:r>
-            <a:endParaRPr lang="en-US"/>
           </a:p>
         </p:txBody>
       </p:sp>
@@ -1667,7 +1669,7 @@
           <a:p>
             <a:pPr lvl="0"/>
             <a:r>
-              <a:rPr lang="en-US" smtClean="0"/>
+              <a:rPr lang="en-US"/>
               <a:t>Click to edit Master text styles</a:t>
             </a:r>
           </a:p>
@@ -1723,38 +1725,37 @@
           <a:p>
             <a:pPr lvl="0"/>
             <a:r>
-              <a:rPr lang="en-US" smtClean="0"/>
+              <a:rPr lang="en-US"/>
               <a:t>Click to edit Master text styles</a:t>
             </a:r>
           </a:p>
           <a:p>
             <a:pPr lvl="1"/>
             <a:r>
-              <a:rPr lang="en-US" smtClean="0"/>
+              <a:rPr lang="en-US"/>
               <a:t>Second level</a:t>
             </a:r>
           </a:p>
           <a:p>
             <a:pPr lvl="2"/>
             <a:r>
-              <a:rPr lang="en-US" smtClean="0"/>
+              <a:rPr lang="en-US"/>
               <a:t>Third level</a:t>
             </a:r>
           </a:p>
           <a:p>
             <a:pPr lvl="3"/>
             <a:r>
-              <a:rPr lang="en-US" smtClean="0"/>
+              <a:rPr lang="en-US"/>
               <a:t>Fourth level</a:t>
             </a:r>
           </a:p>
           <a:p>
             <a:pPr lvl="4"/>
             <a:r>
-              <a:rPr lang="en-US" smtClean="0"/>
+              <a:rPr lang="en-US"/>
               <a:t>Fifth level</a:t>
             </a:r>
-            <a:endParaRPr lang="en-US"/>
           </a:p>
         </p:txBody>
       </p:sp>
@@ -1775,7 +1776,7 @@
           <a:p>
             <a:fld id="{5BCAD085-E8A6-8845-BD4E-CB4CCA059FC4}" type="datetimeFigureOut">
               <a:rPr lang="en-US" smtClean="0"/>
-              <a:t>1/27/13</a:t>
+              <a:t>10/15/2026</a:t>
             </a:fld>
             <a:endParaRPr lang="en-US"/>
           </a:p>
@@ -1869,10 +1870,9 @@
           <a:lstStyle/>
           <a:p>
             <a:r>
-              <a:rPr lang="en-US" smtClean="0"/>
+              <a:rPr lang="en-US"/>
               <a:t>Click to edit Master title style</a:t>
             </a:r>
-            <a:endParaRPr lang="en-US"/>
           </a:p>
         </p:txBody>
       </p:sp>
@@ -1893,7 +1893,7 @@
           <a:p>
             <a:fld id="{5BCAD085-E8A6-8845-BD4E-CB4CCA059FC4}" type="datetimeFigureOut">
               <a:rPr lang="en-US" smtClean="0"/>
-              <a:t>1/27/13</a:t>
+              <a:t>10/15/2026</a:t>
             </a:fld>
             <a:endParaRPr lang="en-US"/>
           </a:p>
@@ -1988,7 +1988,7 @@
           <a:p>
             <a:fld id="{5BCAD085-E8A6-8845-BD4E-CB4CCA059FC4}" type="datetimeFigureOut">
               <a:rPr lang="en-US" smtClean="0"/>
-              <a:t>1/27/13</a:t>
+              <a:t>10/15/2026</a:t>
             </a:fld>
             <a:endParaRPr lang="en-US"/>
           </a:p>
@@ -2091,10 +2091,9 @@
           </a:lstStyle>
           <a:p>
             <a:r>
-              <a:rPr lang="en-US" smtClean="0"/>
+              <a:rPr lang="en-US"/>
               <a:t>Click to edit Master title style</a:t>
             </a:r>
-            <a:endParaRPr lang="en-US"/>
           </a:p>
         </p:txBody>
       </p:sp>
@@ -2148,38 +2147,37 @@
           <a:p>
             <a:pPr lvl="0"/>
             <a:r>
-              <a:rPr lang="en-US" smtClean="0"/>
+              <a:rPr lang="en-US"/>
               <a:t>Click to edit Master text styles</a:t>
             </a:r>
           </a:p>
           <a:p>
             <a:pPr lvl="1"/>
             <a:r>
-              <a:rPr lang="en-US" smtClean="0"/>
+              <a:rPr lang="en-US"/>
               <a:t>Second level</a:t>
             </a:r>
           </a:p>
           <a:p>
             <a:pPr lvl="2"/>
             <a:r>
-              <a:rPr lang="en-US" smtClean="0"/>
+              <a:rPr lang="en-US"/>
               <a:t>Third level</a:t>
             </a:r>
           </a:p>
           <a:p>
             <a:pPr lvl="3"/>
             <a:r>
-              <a:rPr lang="en-US" smtClean="0"/>
+              <a:rPr lang="en-US"/>
               <a:t>Fourth level</a:t>
             </a:r>
           </a:p>
           <a:p>
             <a:pPr lvl="4"/>
             <a:r>
-              <a:rPr lang="en-US" smtClean="0"/>
+              <a:rPr lang="en-US"/>
               <a:t>Fifth level</a:t>
             </a:r>
-            <a:endParaRPr lang="en-US"/>
           </a:p>
         </p:txBody>
       </p:sp>
@@ -2242,7 +2240,7 @@
           <a:p>
             <a:pPr lvl="0"/>
             <a:r>
-              <a:rPr lang="en-US" smtClean="0"/>
+              <a:rPr lang="en-US"/>
               <a:t>Click to edit Master text styles</a:t>
             </a:r>
           </a:p>
@@ -2265,7 +2263,7 @@
           <a:p>
             <a:fld id="{5BCAD085-E8A6-8845-BD4E-CB4CCA059FC4}" type="datetimeFigureOut">
               <a:rPr lang="en-US" smtClean="0"/>
-              <a:t>1/27/13</a:t>
+              <a:t>10/15/2026</a:t>
             </a:fld>
             <a:endParaRPr lang="en-US"/>
           </a:p>
@@ -2368,10 +2366,9 @@
           </a:lstStyle>
           <a:p>
             <a:r>
-              <a:rPr lang="en-US" smtClean="0"/>
+              <a:rPr lang="en-US"/>
               <a:t>Click to edit Master title style</a:t>
             </a:r>
-            <a:endParaRPr lang="en-US"/>
           </a:p>
         </p:txBody>
       </p:sp>
@@ -2495,7 +2492,7 @@
           <a:p>
             <a:pPr lvl="0"/>
             <a:r>
-              <a:rPr lang="en-US" smtClean="0"/>
+              <a:rPr lang="en-US"/>
               <a:t>Click to edit Master text styles</a:t>
             </a:r>
           </a:p>
@@ -2518,7 +2515,7 @@
           <a:p>
             <a:fld id="{5BCAD085-E8A6-8845-BD4E-CB4CCA059FC4}" type="datetimeFigureOut">
               <a:rPr lang="en-US" smtClean="0"/>
-              <a:t>1/27/13</a:t>
+              <a:t>10/15/2026</a:t>
             </a:fld>
             <a:endParaRPr lang="en-US"/>
           </a:p>
@@ -2627,10 +2624,9 @@
           <a:lstStyle/>
           <a:p>
             <a:r>
-              <a:rPr lang="en-US" smtClean="0"/>
+              <a:rPr lang="en-US"/>
               <a:t>Click to edit Master title style</a:t>
             </a:r>
-            <a:endParaRPr lang="en-US"/>
           </a:p>
         </p:txBody>
       </p:sp>
@@ -2661,38 +2657,37 @@
           <a:p>
             <a:pPr lvl="0"/>
             <a:r>
-              <a:rPr lang="en-US" smtClean="0"/>
+              <a:rPr lang="en-US"/>
               <a:t>Click to edit Master text styles</a:t>
             </a:r>
           </a:p>
           <a:p>
             <a:pPr lvl="1"/>
             <a:r>
-              <a:rPr lang="en-US" smtClean="0"/>
+              <a:rPr lang="en-US"/>
               <a:t>Second level</a:t>
             </a:r>
           </a:p>
           <a:p>
             <a:pPr lvl="2"/>
             <a:r>
-              <a:rPr lang="en-US" smtClean="0"/>
+              <a:rPr lang="en-US"/>
               <a:t>Third level</a:t>
             </a:r>
           </a:p>
           <a:p>
             <a:pPr lvl="3"/>
             <a:r>
-              <a:rPr lang="en-US" smtClean="0"/>
+              <a:rPr lang="en-US"/>
               <a:t>Fourth level</a:t>
             </a:r>
           </a:p>
           <a:p>
             <a:pPr lvl="4"/>
             <a:r>
-              <a:rPr lang="en-US" smtClean="0"/>
+              <a:rPr lang="en-US"/>
               <a:t>Fifth level</a:t>
             </a:r>
-            <a:endParaRPr lang="en-US"/>
           </a:p>
         </p:txBody>
       </p:sp>
@@ -2731,7 +2726,7 @@
           <a:p>
             <a:fld id="{5BCAD085-E8A6-8845-BD4E-CB4CCA059FC4}" type="datetimeFigureOut">
               <a:rPr lang="en-US" smtClean="0"/>
-              <a:t>1/27/13</a:t>
+              <a:t>10/15/2026</a:t>
             </a:fld>
             <a:endParaRPr lang="en-US"/>
           </a:p>
@@ -3090,7 +3085,7 @@
 </file>
 
 <file path=ppt/slides/slide1.xml><?xml version="1.0" encoding="utf-8"?>
-<p:sld xmlns:a="http://schemas.openxmlformats.org/drawingml/2006/main" xmlns:p="http://schemas.openxmlformats.org/presentationml/2006/main" xmlns:r="http://schemas.openxmlformats.org/officeDocument/2006/relationships">
+<p:sld xmlns:a="http://schemas.openxmlformats.org/drawingml/2006/main" xmlns:r="http://schemas.openxmlformats.org/officeDocument/2006/relationships" xmlns:p="http://schemas.openxmlformats.org/presentationml/2006/main">
   <p:cSld>
     <p:spTree>
       <p:nvGrpSpPr>
@@ -3098,7 +3093,14 @@
         <p:cNvGrpSpPr/>
         <p:nvPr/>
       </p:nvGrpSpPr>
-      <p:grpSpPr/>
+      <p:grpSpPr>
+        <a:xfrm>
+          <a:off x="0" y="0"/>
+          <a:ext cx="0" cy="0"/>
+          <a:chOff x="0" y="0"/>
+          <a:chExt cx="0" cy="0"/>
+        </a:xfrm>
+      </p:grpSpPr>
       <p:sp>
         <p:nvSpPr>
           <p:cNvPr id="2" name="Rectangle 1"/>
@@ -3139,6 +3141,7 @@
           <a:lstStyle/>
           <a:p>
             <a:pPr algn="ctr"/>
+            <a:endParaRPr/>
           </a:p>
         </p:txBody>
       </p:sp>
@@ -3151,7 +3154,7 @@
         <p:spPr>
           <a:xfrm>
             <a:off x="914400" y="731520"/>
-            <a:ext cx="10362895" cy="2011680"/>
+            <a:ext cx="10362895" cy="1451679"/>
           </a:xfrm>
           <a:prstGeom prst="rect">
             <a:avLst/>
@@ -3172,7 +3175,16 @@
               </a:defRPr>
             </a:pPr>
             <a:r>
-              <a:t>GROUP MINI PROJECT | PEMBELAJARAN MESIN &amp; MACHINE LEARNING (PMML)</a:t>
+              <a:rPr dirty="0"/>
+              <a:t>GROUP MINI PROJECT | PEMBELAJARAN </a:t>
+            </a:r>
+            <a:r>
+              <a:rPr lang="en-US" dirty="0"/>
+              <a:t>MESIN MENDALAM LANJUT</a:t>
+            </a:r>
+            <a:r>
+              <a:rPr dirty="0"/>
+              <a:t> (PMML)</a:t>
             </a:r>
           </a:p>
           <a:p>
@@ -3187,7 +3199,44 @@
               </a:defRPr>
             </a:pPr>
             <a:r>
-              <a:t>Klasifikasi Diagnosis Kanker Payudara Menggunakan Deep Neural Network &amp; Residual MLP Berbasis Secondary Dataset UCI</a:t>
+              <a:rPr dirty="0" err="1"/>
+              <a:t>Klasifikasi</a:t>
+            </a:r>
+            <a:r>
+              <a:rPr dirty="0"/>
+              <a:t> Diagnosis </a:t>
+            </a:r>
+            <a:r>
+              <a:rPr dirty="0" err="1"/>
+              <a:t>Kanker</a:t>
+            </a:r>
+            <a:r>
+              <a:rPr dirty="0"/>
+              <a:t> </a:t>
+            </a:r>
+            <a:r>
+              <a:rPr dirty="0" err="1"/>
+              <a:t>Payudara</a:t>
+            </a:r>
+            <a:r>
+              <a:rPr dirty="0"/>
+              <a:t> </a:t>
+            </a:r>
+            <a:r>
+              <a:rPr dirty="0" err="1"/>
+              <a:t>Menggunakan</a:t>
+            </a:r>
+            <a:r>
+              <a:rPr dirty="0"/>
+              <a:t> Deep Neural Network &amp; Residual MLP </a:t>
+            </a:r>
+            <a:r>
+              <a:rPr dirty="0" err="1"/>
+              <a:t>Berbasis</a:t>
+            </a:r>
+            <a:r>
+              <a:rPr dirty="0"/>
+              <a:t> Secondary Dataset UCI</a:t>
             </a:r>
           </a:p>
           <a:p>
@@ -3202,8 +3251,42 @@
               </a:defRPr>
             </a:pPr>
             <a:r>
-              <a:t>Dosen Pengampu: Afiahayati, S.Kom., M.Cs., Ph.D</a:t>
-            </a:r>
+              <a:rPr dirty="0" err="1"/>
+              <a:t>Dosen</a:t>
+            </a:r>
+            <a:r>
+              <a:rPr dirty="0"/>
+              <a:t> </a:t>
+            </a:r>
+            <a:r>
+              <a:rPr dirty="0" err="1"/>
+              <a:t>Pengampu</a:t>
+            </a:r>
+            <a:r>
+              <a:rPr dirty="0"/>
+              <a:t>: </a:t>
+            </a:r>
+            <a:r>
+              <a:rPr dirty="0" err="1"/>
+              <a:t>Afiahayati</a:t>
+            </a:r>
+            <a:r>
+              <a:rPr dirty="0"/>
+              <a:t>, </a:t>
+            </a:r>
+            <a:r>
+              <a:rPr dirty="0" err="1"/>
+              <a:t>S.Kom</a:t>
+            </a:r>
+            <a:r>
+              <a:rPr dirty="0"/>
+              <a:t>., M.Cs., </a:t>
+            </a:r>
+            <a:r>
+              <a:rPr dirty="0" err="1"/>
+              <a:t>Ph.D</a:t>
+            </a:r>
+            <a:endParaRPr dirty="0"/>
           </a:p>
         </p:txBody>
       </p:sp>
@@ -3245,7 +3328,7 @@
           </a:fontRef>
         </p:style>
         <p:txBody>
-          <a:bodyPr rtlCol="0" anchor="ctr" wrap="square" lIns="164592" rIns="164592" tIns="228600"/>
+          <a:bodyPr wrap="square" lIns="164592" tIns="228600" rIns="164592" rtlCol="0" anchor="ctr"/>
           <a:lstStyle/>
           <a:p>
             <a:pPr algn="ctr">
@@ -3256,6 +3339,7 @@
               </a:defRPr>
             </a:pPr>
             <a:r>
+              <a:rPr dirty="0"/>
               <a:t>ANGGOTA 1</a:t>
             </a:r>
           </a:p>
@@ -3271,6 +3355,7 @@
               </a:defRPr>
             </a:pPr>
             <a:r>
+              <a:rPr dirty="0"/>
               <a:t>FRANS ALWAN PURBA</a:t>
             </a:r>
           </a:p>
@@ -3286,6 +3371,7 @@
               </a:defRPr>
             </a:pPr>
             <a:r>
+              <a:rPr dirty="0"/>
               <a:t>25/563545/PPA/07116</a:t>
             </a:r>
           </a:p>
@@ -3301,12 +3387,33 @@
               </a:defRPr>
             </a:pPr>
             <a:r>
-              <a:t>Magister Ilmu Komputer</a:t>
-            </a:r>
-            <a:br/>
-            <a:r>
-              <a:t>Universitas Gadjah Mada</a:t>
-            </a:r>
+              <a:rPr dirty="0"/>
+              <a:t>Magister </a:t>
+            </a:r>
+            <a:r>
+              <a:rPr lang="en-US" dirty="0" err="1"/>
+              <a:t>Kecerdasan</a:t>
+            </a:r>
+            <a:r>
+              <a:rPr lang="en-US" dirty="0"/>
+              <a:t> </a:t>
+            </a:r>
+            <a:r>
+              <a:rPr lang="en-US" dirty="0" err="1"/>
+              <a:t>Artifisial</a:t>
+            </a:r>
+            <a:br>
+              <a:rPr dirty="0"/>
+            </a:br>
+            <a:r>
+              <a:rPr dirty="0"/>
+              <a:t>Universitas Gadjah </a:t>
+            </a:r>
+            <a:r>
+              <a:rPr dirty="0" err="1"/>
+              <a:t>Mada</a:t>
+            </a:r>
+            <a:endParaRPr dirty="0"/>
           </a:p>
         </p:txBody>
       </p:sp>
@@ -3348,7 +3455,7 @@
           </a:fontRef>
         </p:style>
         <p:txBody>
-          <a:bodyPr rtlCol="0" anchor="ctr" wrap="square" lIns="164592" rIns="164592" tIns="228600"/>
+          <a:bodyPr wrap="square" lIns="164592" tIns="228600" rIns="164592" rtlCol="0" anchor="ctr"/>
           <a:lstStyle/>
           <a:p>
             <a:pPr algn="ctr">
@@ -3359,6 +3466,7 @@
               </a:defRPr>
             </a:pPr>
             <a:r>
+              <a:rPr dirty="0"/>
               <a:t>ANGGOTA 2</a:t>
             </a:r>
           </a:p>
@@ -3374,7 +3482,16 @@
               </a:defRPr>
             </a:pPr>
             <a:r>
-              <a:t>Muhammad Fikry Rizal</a:t>
+              <a:rPr dirty="0"/>
+              <a:t>Muhammad </a:t>
+            </a:r>
+            <a:r>
+              <a:rPr dirty="0" err="1"/>
+              <a:t>Fikry</a:t>
+            </a:r>
+            <a:r>
+              <a:rPr dirty="0"/>
+              <a:t> Rizal</a:t>
             </a:r>
           </a:p>
           <a:p>
@@ -3389,6 +3506,7 @@
               </a:defRPr>
             </a:pPr>
             <a:r>
+              <a:rPr dirty="0"/>
               <a:t>25/573936/PPA/07229</a:t>
             </a:r>
           </a:p>
@@ -3404,12 +3522,33 @@
               </a:defRPr>
             </a:pPr>
             <a:r>
-              <a:t>Magister Ilmu Komputer</a:t>
-            </a:r>
-            <a:br/>
-            <a:r>
-              <a:t>Universitas Gadjah Mada</a:t>
-            </a:r>
+              <a:rPr lang="en-US" dirty="0"/>
+              <a:t>Magister </a:t>
+            </a:r>
+            <a:r>
+              <a:rPr lang="en-US" dirty="0" err="1"/>
+              <a:t>Kecerdasan</a:t>
+            </a:r>
+            <a:r>
+              <a:rPr lang="en-US" dirty="0"/>
+              <a:t> </a:t>
+            </a:r>
+            <a:r>
+              <a:rPr lang="en-US" dirty="0" err="1"/>
+              <a:t>Artifisial</a:t>
+            </a:r>
+            <a:br>
+              <a:rPr dirty="0"/>
+            </a:br>
+            <a:r>
+              <a:rPr dirty="0"/>
+              <a:t>Universitas Gadjah </a:t>
+            </a:r>
+            <a:r>
+              <a:rPr dirty="0" err="1"/>
+              <a:t>Mada</a:t>
+            </a:r>
+            <a:endParaRPr dirty="0"/>
           </a:p>
         </p:txBody>
       </p:sp>
@@ -3451,7 +3590,7 @@
           </a:fontRef>
         </p:style>
         <p:txBody>
-          <a:bodyPr rtlCol="0" anchor="ctr" wrap="square" lIns="164592" rIns="164592" tIns="228600"/>
+          <a:bodyPr wrap="square" lIns="164592" tIns="228600" rIns="164592" rtlCol="0" anchor="ctr"/>
           <a:lstStyle/>
           <a:p>
             <a:pPr algn="ctr">
@@ -3462,6 +3601,7 @@
               </a:defRPr>
             </a:pPr>
             <a:r>
+              <a:rPr dirty="0"/>
               <a:t>ANGGOTA 3</a:t>
             </a:r>
           </a:p>
@@ -3477,8 +3617,18 @@
               </a:defRPr>
             </a:pPr>
             <a:r>
-              <a:t>Rafel Romero Hirawanto</a:t>
-            </a:r>
+              <a:rPr dirty="0" err="1"/>
+              <a:t>Rafel</a:t>
+            </a:r>
+            <a:r>
+              <a:rPr dirty="0"/>
+              <a:t> Romero </a:t>
+            </a:r>
+            <a:r>
+              <a:rPr dirty="0" err="1"/>
+              <a:t>Hirawanto</a:t>
+            </a:r>
+            <a:endParaRPr dirty="0"/>
           </a:p>
           <a:p>
             <a:pPr>
@@ -3492,6 +3642,7 @@
               </a:defRPr>
             </a:pPr>
             <a:r>
+              <a:rPr dirty="0"/>
               <a:t>25/573260/PPA/07216</a:t>
             </a:r>
           </a:p>
@@ -3507,12 +3658,33 @@
               </a:defRPr>
             </a:pPr>
             <a:r>
-              <a:t>Magister Ilmu Komputer</a:t>
-            </a:r>
-            <a:br/>
-            <a:r>
-              <a:t>Universitas Gadjah Mada</a:t>
-            </a:r>
+              <a:rPr lang="en-US" dirty="0"/>
+              <a:t>Magister </a:t>
+            </a:r>
+            <a:r>
+              <a:rPr lang="en-US" dirty="0" err="1"/>
+              <a:t>Kecerdasan</a:t>
+            </a:r>
+            <a:r>
+              <a:rPr lang="en-US" dirty="0"/>
+              <a:t> </a:t>
+            </a:r>
+            <a:r>
+              <a:rPr lang="en-US" dirty="0" err="1"/>
+              <a:t>Artifisial</a:t>
+            </a:r>
+            <a:br>
+              <a:rPr dirty="0"/>
+            </a:br>
+            <a:r>
+              <a:rPr dirty="0"/>
+              <a:t>Universitas Gadjah </a:t>
+            </a:r>
+            <a:r>
+              <a:rPr dirty="0" err="1"/>
+              <a:t>Mada</a:t>
+            </a:r>
+            <a:endParaRPr dirty="0"/>
           </a:p>
         </p:txBody>
       </p:sp>
@@ -3554,7 +3726,7 @@
           </a:fontRef>
         </p:style>
         <p:txBody>
-          <a:bodyPr rtlCol="0" anchor="ctr" wrap="square" lIns="164592" rIns="164592" tIns="228600"/>
+          <a:bodyPr wrap="square" lIns="164592" tIns="228600" rIns="164592" rtlCol="0" anchor="ctr"/>
           <a:lstStyle/>
           <a:p>
             <a:pPr algn="ctr">
@@ -3565,6 +3737,7 @@
               </a:defRPr>
             </a:pPr>
             <a:r>
+              <a:rPr dirty="0"/>
               <a:t>ANGGOTA 4</a:t>
             </a:r>
           </a:p>
@@ -3580,7 +3753,12 @@
               </a:defRPr>
             </a:pPr>
             <a:r>
-              <a:t>Sidikara Hakim</a:t>
+              <a:rPr dirty="0" err="1"/>
+              <a:t>Sidikara</a:t>
+            </a:r>
+            <a:r>
+              <a:rPr dirty="0"/>
+              <a:t> Hakim</a:t>
             </a:r>
           </a:p>
           <a:p>
@@ -3595,6 +3773,7 @@
               </a:defRPr>
             </a:pPr>
             <a:r>
+              <a:rPr dirty="0"/>
               <a:t>25/573720/PPA/07221</a:t>
             </a:r>
           </a:p>
@@ -3610,12 +3789,33 @@
               </a:defRPr>
             </a:pPr>
             <a:r>
-              <a:t>Magister Ilmu Komputer</a:t>
-            </a:r>
-            <a:br/>
-            <a:r>
-              <a:t>Universitas Gadjah Mada</a:t>
-            </a:r>
+              <a:rPr lang="en-US" dirty="0"/>
+              <a:t>Magister </a:t>
+            </a:r>
+            <a:r>
+              <a:rPr lang="en-US" dirty="0" err="1"/>
+              <a:t>Kecerdasan</a:t>
+            </a:r>
+            <a:r>
+              <a:rPr lang="en-US" dirty="0"/>
+              <a:t> </a:t>
+            </a:r>
+            <a:r>
+              <a:rPr lang="en-US" dirty="0" err="1"/>
+              <a:t>Artifisial</a:t>
+            </a:r>
+            <a:br>
+              <a:rPr dirty="0"/>
+            </a:br>
+            <a:r>
+              <a:rPr dirty="0"/>
+              <a:t>Universitas Gadjah </a:t>
+            </a:r>
+            <a:r>
+              <a:rPr dirty="0" err="1"/>
+              <a:t>Mada</a:t>
+            </a:r>
+            <a:endParaRPr dirty="0"/>
           </a:p>
         </p:txBody>
       </p:sp>
@@ -3663,7 +3863,7 @@
 </file>
 
 <file path=ppt/slides/slide10.xml><?xml version="1.0" encoding="utf-8"?>
-<p:sld xmlns:a="http://schemas.openxmlformats.org/drawingml/2006/main" xmlns:p="http://schemas.openxmlformats.org/presentationml/2006/main" xmlns:r="http://schemas.openxmlformats.org/officeDocument/2006/relationships">
+<p:sld xmlns:a="http://schemas.openxmlformats.org/drawingml/2006/main" xmlns:r="http://schemas.openxmlformats.org/officeDocument/2006/relationships" xmlns:p="http://schemas.openxmlformats.org/presentationml/2006/main">
   <p:cSld>
     <p:spTree>
       <p:nvGrpSpPr>
@@ -3671,7 +3871,14 @@
         <p:cNvGrpSpPr/>
         <p:nvPr/>
       </p:nvGrpSpPr>
-      <p:grpSpPr/>
+      <p:grpSpPr>
+        <a:xfrm>
+          <a:off x="0" y="0"/>
+          <a:ext cx="0" cy="0"/>
+          <a:chOff x="0" y="0"/>
+          <a:chExt cx="0" cy="0"/>
+        </a:xfrm>
+      </p:grpSpPr>
       <p:sp>
         <p:nvSpPr>
           <p:cNvPr id="2" name="TextBox 1"/>
@@ -3816,6 +4023,7 @@
           <a:lstStyle/>
           <a:p>
             <a:pPr algn="ctr"/>
+            <a:endParaRPr/>
           </a:p>
         </p:txBody>
       </p:sp>
@@ -3857,7 +4065,7 @@
           </a:fontRef>
         </p:style>
         <p:txBody>
-          <a:bodyPr rtlCol="0" anchor="ctr" wrap="square" lIns="182880" rIns="182880" tIns="182880"/>
+          <a:bodyPr wrap="square" lIns="182880" tIns="182880" rIns="182880" rtlCol="0" anchor="ctr"/>
           <a:lstStyle/>
           <a:p>
             <a:pPr algn="ctr">
@@ -3926,7 +4134,7 @@
           </a:fontRef>
         </p:style>
         <p:txBody>
-          <a:bodyPr rtlCol="0" anchor="ctr" wrap="square" lIns="182880" rIns="182880" tIns="182880"/>
+          <a:bodyPr wrap="square" lIns="182880" tIns="182880" rIns="182880" rtlCol="0" anchor="ctr"/>
           <a:lstStyle/>
           <a:p>
             <a:pPr algn="ctr">
@@ -3995,7 +4203,7 @@
           </a:fontRef>
         </p:style>
         <p:txBody>
-          <a:bodyPr rtlCol="0" anchor="ctr" wrap="square" lIns="182880" rIns="182880" tIns="182880"/>
+          <a:bodyPr wrap="square" lIns="182880" tIns="182880" rIns="182880" rtlCol="0" anchor="ctr"/>
           <a:lstStyle/>
           <a:p>
             <a:pPr algn="ctr">
@@ -4064,7 +4272,7 @@
           </a:fontRef>
         </p:style>
         <p:txBody>
-          <a:bodyPr rtlCol="0" anchor="ctr" wrap="square" lIns="182880" rIns="182880" tIns="182880"/>
+          <a:bodyPr wrap="square" lIns="182880" tIns="182880" rIns="182880" rtlCol="0" anchor="ctr"/>
           <a:lstStyle/>
           <a:p>
             <a:pPr algn="ctr">
@@ -4104,7 +4312,7 @@
 </file>
 
 <file path=ppt/slides/slide11.xml><?xml version="1.0" encoding="utf-8"?>
-<p:sld xmlns:a="http://schemas.openxmlformats.org/drawingml/2006/main" xmlns:p="http://schemas.openxmlformats.org/presentationml/2006/main" xmlns:r="http://schemas.openxmlformats.org/officeDocument/2006/relationships">
+<p:sld xmlns:a="http://schemas.openxmlformats.org/drawingml/2006/main" xmlns:r="http://schemas.openxmlformats.org/officeDocument/2006/relationships" xmlns:p="http://schemas.openxmlformats.org/presentationml/2006/main">
   <p:cSld>
     <p:spTree>
       <p:nvGrpSpPr>
@@ -4112,7 +4320,14 @@
         <p:cNvGrpSpPr/>
         <p:nvPr/>
       </p:nvGrpSpPr>
-      <p:grpSpPr/>
+      <p:grpSpPr>
+        <a:xfrm>
+          <a:off x="0" y="0"/>
+          <a:ext cx="0" cy="0"/>
+          <a:chOff x="0" y="0"/>
+          <a:chExt cx="0" cy="0"/>
+        </a:xfrm>
+      </p:grpSpPr>
       <p:sp>
         <p:nvSpPr>
           <p:cNvPr id="2" name="TextBox 1"/>
@@ -4257,6 +4472,7 @@
           <a:lstStyle/>
           <a:p>
             <a:pPr algn="ctr"/>
+            <a:endParaRPr/>
           </a:p>
         </p:txBody>
       </p:sp>
@@ -4298,7 +4514,7 @@
           </a:fontRef>
         </p:style>
         <p:txBody>
-          <a:bodyPr rtlCol="0" anchor="ctr" wrap="square" lIns="228600" rIns="228600" tIns="228600"/>
+          <a:bodyPr wrap="square" lIns="228600" tIns="228600" rIns="228600" rtlCol="0" anchor="ctr"/>
           <a:lstStyle/>
           <a:p>
             <a:pPr algn="ctr">
@@ -4309,8 +4525,26 @@
               </a:defRPr>
             </a:pPr>
             <a:r>
-              <a:t>Tautan Repositori GitHub &amp; Kode Sumber</a:t>
-            </a:r>
+              <a:rPr dirty="0" err="1"/>
+              <a:t>Tautan</a:t>
+            </a:r>
+            <a:r>
+              <a:rPr dirty="0"/>
+              <a:t> </a:t>
+            </a:r>
+            <a:r>
+              <a:rPr dirty="0" err="1"/>
+              <a:t>Repositori</a:t>
+            </a:r>
+            <a:r>
+              <a:rPr dirty="0"/>
+              <a:t> GitHub &amp; Kode </a:t>
+            </a:r>
+            <a:r>
+              <a:rPr dirty="0" err="1"/>
+              <a:t>Sumber</a:t>
+            </a:r>
+            <a:endParaRPr dirty="0"/>
           </a:p>
           <a:p>
             <a:pPr>
@@ -4324,6 +4558,7 @@
               </a:defRPr>
             </a:pPr>
             <a:r>
+              <a:rPr dirty="0"/>
               <a:t>GitHub URL: https://github.com/fransalwan/pmml-mini-project</a:t>
             </a:r>
           </a:p>
@@ -4339,7 +4574,24 @@
               </a:defRPr>
             </a:pPr>
             <a:r>
-              <a:t>Langkah Reproduksi Proyek (Reproducibility):</a:t>
+              <a:rPr dirty="0"/>
+              <a:t>Langkah </a:t>
+            </a:r>
+            <a:r>
+              <a:rPr dirty="0" err="1"/>
+              <a:t>Reproduksi</a:t>
+            </a:r>
+            <a:r>
+              <a:rPr dirty="0"/>
+              <a:t> </a:t>
+            </a:r>
+            <a:r>
+              <a:rPr dirty="0" err="1"/>
+              <a:t>Proyek</a:t>
+            </a:r>
+            <a:r>
+              <a:rPr dirty="0"/>
+              <a:t> (Reproducibility):</a:t>
             </a:r>
           </a:p>
           <a:p>
@@ -4354,7 +4606,24 @@
               </a:defRPr>
             </a:pPr>
             <a:r>
-              <a:t>1. Clone repositori: git clone &lt;repo_url&gt;</a:t>
+              <a:rPr dirty="0"/>
+              <a:t>1. Clone </a:t>
+            </a:r>
+            <a:r>
+              <a:rPr dirty="0" err="1"/>
+              <a:t>repositori</a:t>
+            </a:r>
+            <a:r>
+              <a:rPr dirty="0"/>
+              <a:t>: git clone &lt;</a:t>
+            </a:r>
+            <a:r>
+              <a:rPr dirty="0" err="1"/>
+              <a:t>repo_url</a:t>
+            </a:r>
+            <a:r>
+              <a:rPr dirty="0"/>
+              <a:t>&gt;</a:t>
             </a:r>
           </a:p>
           <a:p>
@@ -4369,7 +4638,32 @@
               </a:defRPr>
             </a:pPr>
             <a:r>
-              <a:t>2. Masuk ke direktori: cd pmml-mini-project</a:t>
+              <a:rPr dirty="0"/>
+              <a:t>2. Masuk </a:t>
+            </a:r>
+            <a:r>
+              <a:rPr dirty="0" err="1"/>
+              <a:t>ke</a:t>
+            </a:r>
+            <a:r>
+              <a:rPr dirty="0"/>
+              <a:t> </a:t>
+            </a:r>
+            <a:r>
+              <a:rPr dirty="0" err="1"/>
+              <a:t>direktori</a:t>
+            </a:r>
+            <a:r>
+              <a:rPr dirty="0"/>
+              <a:t>: cd </a:t>
+            </a:r>
+            <a:r>
+              <a:rPr dirty="0" err="1"/>
+              <a:t>pmml</a:t>
+            </a:r>
+            <a:r>
+              <a:rPr dirty="0"/>
+              <a:t>-mini-project</a:t>
             </a:r>
           </a:p>
           <a:p>
@@ -4384,7 +4678,16 @@
               </a:defRPr>
             </a:pPr>
             <a:r>
-              <a:t>3. Install dependensi: pip install -r requirements.txt</a:t>
+              <a:rPr dirty="0"/>
+              <a:t>3. Install </a:t>
+            </a:r>
+            <a:r>
+              <a:rPr dirty="0" err="1"/>
+              <a:t>dependensi</a:t>
+            </a:r>
+            <a:r>
+              <a:rPr dirty="0"/>
+              <a:t>: pip install -r requirements.txt</a:t>
             </a:r>
           </a:p>
           <a:p>
@@ -4399,7 +4702,24 @@
               </a:defRPr>
             </a:pPr>
             <a:r>
-              <a:t>4. Jalankan eksperimen: python src/train_eval.py</a:t>
+              <a:rPr dirty="0"/>
+              <a:t>4. </a:t>
+            </a:r>
+            <a:r>
+              <a:rPr dirty="0" err="1"/>
+              <a:t>Jalankan</a:t>
+            </a:r>
+            <a:r>
+              <a:rPr dirty="0"/>
+              <a:t> </a:t>
+            </a:r>
+            <a:r>
+              <a:rPr dirty="0" err="1"/>
+              <a:t>eksperimen</a:t>
+            </a:r>
+            <a:r>
+              <a:rPr dirty="0"/>
+              <a:t>: python src/train_eval.py</a:t>
             </a:r>
           </a:p>
           <a:p>
@@ -4414,7 +4734,16 @@
               </a:defRPr>
             </a:pPr>
             <a:r>
-              <a:t>5. Generate grafik: python src/generate_plots.py</a:t>
+              <a:rPr dirty="0"/>
+              <a:t>5. Generate </a:t>
+            </a:r>
+            <a:r>
+              <a:rPr dirty="0" err="1"/>
+              <a:t>grafik</a:t>
+            </a:r>
+            <a:r>
+              <a:rPr dirty="0"/>
+              <a:t>: python src/generate_plots.py</a:t>
             </a:r>
           </a:p>
           <a:p>
@@ -4429,23 +4758,30 @@
               </a:defRPr>
             </a:pPr>
             <a:r>
-              <a:t>6. Buka Jupyter Notebook: jupyter notebook pmml_mini_project.ipynb</a:t>
-            </a:r>
-          </a:p>
-          <a:p>
-            <a:pPr>
-              <a:spcBef>
-                <a:spcPts val="300"/>
-              </a:spcBef>
-              <a:defRPr sz="950">
-                <a:solidFill>
-                  <a:srgbClr val="191E28"/>
-                </a:solidFill>
-              </a:defRPr>
-            </a:pPr>
-            <a:r>
-              <a:t>7. Generate slide presentasi: python generate_presentation.py</a:t>
-            </a:r>
+              <a:rPr dirty="0"/>
+              <a:t>6. Buka </a:t>
+            </a:r>
+            <a:r>
+              <a:rPr dirty="0" err="1"/>
+              <a:t>Jupyter</a:t>
+            </a:r>
+            <a:r>
+              <a:rPr dirty="0"/>
+              <a:t> Notebook: </a:t>
+            </a:r>
+            <a:r>
+              <a:rPr dirty="0" err="1"/>
+              <a:t>jupyter</a:t>
+            </a:r>
+            <a:r>
+              <a:rPr dirty="0"/>
+              <a:t> notebook </a:t>
+            </a:r>
+            <a:r>
+              <a:rPr dirty="0" err="1"/>
+              <a:t>pmml_mini_project.ipynb</a:t>
+            </a:r>
+            <a:endParaRPr dirty="0"/>
           </a:p>
         </p:txBody>
       </p:sp>
@@ -4487,7 +4823,7 @@
           </a:fontRef>
         </p:style>
         <p:txBody>
-          <a:bodyPr rtlCol="0" anchor="ctr" wrap="square" lIns="228600" rIns="228600" tIns="228600"/>
+          <a:bodyPr wrap="square" lIns="228600" tIns="228600" rIns="228600" rtlCol="0" anchor="ctr"/>
           <a:lstStyle/>
           <a:p>
             <a:pPr algn="ctr">
@@ -4498,8 +4834,26 @@
               </a:defRPr>
             </a:pPr>
             <a:r>
-              <a:t>Struktur Direktori Repositori</a:t>
-            </a:r>
+              <a:rPr dirty="0" err="1"/>
+              <a:t>Struktur</a:t>
+            </a:r>
+            <a:r>
+              <a:rPr dirty="0"/>
+              <a:t> </a:t>
+            </a:r>
+            <a:r>
+              <a:rPr dirty="0" err="1"/>
+              <a:t>Direktori</a:t>
+            </a:r>
+            <a:r>
+              <a:rPr dirty="0"/>
+              <a:t> </a:t>
+            </a:r>
+            <a:r>
+              <a:rPr dirty="0" err="1"/>
+              <a:t>Repositori</a:t>
+            </a:r>
+            <a:endParaRPr dirty="0"/>
           </a:p>
           <a:p>
             <a:pPr>
@@ -4514,98 +4868,212 @@
               </a:defRPr>
             </a:pPr>
             <a:r>
-              <a:t>pmml-mini-project/</a:t>
-            </a:r>
-            <a:br/>
-            <a:r>
+              <a:rPr dirty="0" err="1"/>
+              <a:t>pmml</a:t>
+            </a:r>
+            <a:r>
+              <a:rPr dirty="0"/>
+              <a:t>-mini-project/</a:t>
+            </a:r>
+            <a:br>
+              <a:rPr dirty="0"/>
+            </a:br>
+            <a:r>
+              <a:rPr dirty="0"/>
               <a:t>├── assets/                  # 7 Scientific Plots &amp; Figures</a:t>
             </a:r>
-            <a:br/>
-            <a:r>
+            <a:br>
+              <a:rPr dirty="0"/>
+            </a:br>
+            <a:r>
+              <a:rPr dirty="0"/>
               <a:t>│   ├── fig1_data_distribution.png</a:t>
             </a:r>
-            <a:br/>
-            <a:r>
+            <a:br>
+              <a:rPr dirty="0"/>
+            </a:br>
+            <a:r>
+              <a:rPr dirty="0"/>
               <a:t>│   ├── fig2_architectures.png</a:t>
             </a:r>
-            <a:br/>
-            <a:r>
+            <a:br>
+              <a:rPr dirty="0"/>
+            </a:br>
+            <a:r>
+              <a:rPr dirty="0"/>
               <a:t>│   ├── fig3_kfold_cv_results.png</a:t>
             </a:r>
-            <a:br/>
-            <a:r>
+            <a:br>
+              <a:rPr dirty="0"/>
+            </a:br>
+            <a:r>
+              <a:rPr dirty="0"/>
               <a:t>│   ├── fig4_learning_curves.png</a:t>
             </a:r>
-            <a:br/>
-            <a:r>
+            <a:br>
+              <a:rPr dirty="0"/>
+            </a:br>
+            <a:r>
+              <a:rPr dirty="0"/>
               <a:t>│   ├── fig5_optimizer_tuning.png</a:t>
             </a:r>
-            <a:br/>
-            <a:r>
+            <a:br>
+              <a:rPr dirty="0"/>
+            </a:br>
+            <a:r>
+              <a:rPr dirty="0"/>
               <a:t>│   ├── fig6_test_confusion_matrix.png</a:t>
             </a:r>
-            <a:br/>
-            <a:r>
+            <a:br>
+              <a:rPr dirty="0"/>
+            </a:br>
+            <a:r>
+              <a:rPr dirty="0"/>
               <a:t>│   └── fig7_roc_curves.png</a:t>
             </a:r>
-            <a:br/>
-            <a:r>
+            <a:br>
+              <a:rPr dirty="0"/>
+            </a:br>
+            <a:r>
+              <a:rPr dirty="0"/>
               <a:t>├── data/                    # Secondary Dataset (CSV)</a:t>
             </a:r>
-            <a:br/>
-            <a:r>
+            <a:br>
+              <a:rPr dirty="0"/>
+            </a:br>
+            <a:r>
+              <a:rPr dirty="0"/>
               <a:t>│   └── breast_cancer.csv</a:t>
             </a:r>
-            <a:br/>
-            <a:r>
+            <a:br>
+              <a:rPr dirty="0"/>
+            </a:br>
+            <a:r>
+              <a:rPr dirty="0"/>
               <a:t>├── results/                 # JSON Experiment Outputs</a:t>
             </a:r>
-            <a:br/>
-            <a:r>
-              <a:t>│   ├── kfold_results.json</a:t>
-            </a:r>
-            <a:br/>
-            <a:r>
-              <a:t>│   ├── optimizer_results.json</a:t>
-            </a:r>
-            <a:br/>
-            <a:r>
-              <a:t>│   ├── lr_results.json</a:t>
-            </a:r>
-            <a:br/>
-            <a:r>
-              <a:t>│   └── test_results.json</a:t>
-            </a:r>
-            <a:br/>
-            <a:r>
-              <a:t>├── src/                     # Modular Python Scripts</a:t>
-            </a:r>
-            <a:br/>
-            <a:r>
+            <a:br>
+              <a:rPr dirty="0"/>
+            </a:br>
+            <a:r>
+              <a:rPr dirty="0"/>
+              <a:t>│   ├── </a:t>
+            </a:r>
+            <a:r>
+              <a:rPr dirty="0" err="1"/>
+              <a:t>kfold_results.json</a:t>
+            </a:r>
+            <a:br>
+              <a:rPr dirty="0"/>
+            </a:br>
+            <a:r>
+              <a:rPr dirty="0"/>
+              <a:t>│   ├── </a:t>
+            </a:r>
+            <a:r>
+              <a:rPr dirty="0" err="1"/>
+              <a:t>optimizer_results.json</a:t>
+            </a:r>
+            <a:br>
+              <a:rPr dirty="0"/>
+            </a:br>
+            <a:r>
+              <a:rPr dirty="0"/>
+              <a:t>│   ├── </a:t>
+            </a:r>
+            <a:r>
+              <a:rPr dirty="0" err="1"/>
+              <a:t>lr_results.json</a:t>
+            </a:r>
+            <a:br>
+              <a:rPr dirty="0"/>
+            </a:br>
+            <a:r>
+              <a:rPr dirty="0"/>
+              <a:t>│   └── </a:t>
+            </a:r>
+            <a:r>
+              <a:rPr dirty="0" err="1"/>
+              <a:t>test_results.json</a:t>
+            </a:r>
+            <a:br>
+              <a:rPr dirty="0"/>
+            </a:br>
+            <a:r>
+              <a:rPr dirty="0"/>
+              <a:t>├── </a:t>
+            </a:r>
+            <a:r>
+              <a:rPr dirty="0" err="1"/>
+              <a:t>src</a:t>
+            </a:r>
+            <a:r>
+              <a:rPr dirty="0"/>
+              <a:t>/                     # Modular Python Scripts</a:t>
+            </a:r>
+            <a:br>
+              <a:rPr dirty="0"/>
+            </a:br>
+            <a:r>
+              <a:rPr dirty="0"/>
               <a:t>│   ├── data_loader.py</a:t>
             </a:r>
-            <a:br/>
-            <a:r>
+            <a:br>
+              <a:rPr dirty="0"/>
+            </a:br>
+            <a:r>
+              <a:rPr dirty="0"/>
               <a:t>│   ├── models.py</a:t>
             </a:r>
-            <a:br/>
-            <a:r>
+            <a:br>
+              <a:rPr dirty="0"/>
+            </a:br>
+            <a:r>
+              <a:rPr dirty="0"/>
               <a:t>│   ├── train_eval.py</a:t>
             </a:r>
-            <a:br/>
-            <a:r>
+            <a:br>
+              <a:rPr dirty="0"/>
+            </a:br>
+            <a:r>
+              <a:rPr dirty="0"/>
               <a:t>│   └── generate_plots.py</a:t>
             </a:r>
-            <a:br/>
-            <a:r>
-              <a:t>├── pmml_mini_project.ipynb  # Interactive Jupyter Notebook</a:t>
-            </a:r>
-            <a:br/>
-            <a:r>
+            <a:br>
+              <a:rPr dirty="0"/>
+            </a:br>
+            <a:r>
+              <a:rPr dirty="0"/>
+              <a:t>├── </a:t>
+            </a:r>
+            <a:r>
+              <a:rPr dirty="0" err="1"/>
+              <a:t>pmml_mini_project.ipynb</a:t>
+            </a:r>
+            <a:r>
+              <a:rPr dirty="0"/>
+              <a:t>  # Interactive </a:t>
+            </a:r>
+            <a:r>
+              <a:rPr dirty="0" err="1"/>
+              <a:t>Jupyter</a:t>
+            </a:r>
+            <a:r>
+              <a:rPr dirty="0"/>
+              <a:t> Notebook</a:t>
+            </a:r>
+            <a:br>
+              <a:rPr dirty="0"/>
+            </a:br>
+            <a:r>
+              <a:rPr dirty="0"/>
               <a:t>├── PMML_Mini_Project_Presentation.pptx # 12 Presentation Slides</a:t>
             </a:r>
-            <a:br/>
-            <a:r>
+            <a:br>
+              <a:rPr dirty="0"/>
+            </a:br>
+            <a:r>
+              <a:rPr dirty="0"/>
               <a:t>└── README.md                # Full Documentation Report</a:t>
             </a:r>
           </a:p>
@@ -4620,7 +5088,7 @@
 </file>
 
 <file path=ppt/slides/slide12.xml><?xml version="1.0" encoding="utf-8"?>
-<p:sld xmlns:a="http://schemas.openxmlformats.org/drawingml/2006/main" xmlns:p="http://schemas.openxmlformats.org/presentationml/2006/main" xmlns:r="http://schemas.openxmlformats.org/officeDocument/2006/relationships">
+<p:sld xmlns:a="http://schemas.openxmlformats.org/drawingml/2006/main" xmlns:r="http://schemas.openxmlformats.org/officeDocument/2006/relationships" xmlns:p="http://schemas.openxmlformats.org/presentationml/2006/main">
   <p:cSld>
     <p:spTree>
       <p:nvGrpSpPr>
@@ -4628,7 +5096,14 @@
         <p:cNvGrpSpPr/>
         <p:nvPr/>
       </p:nvGrpSpPr>
-      <p:grpSpPr/>
+      <p:grpSpPr>
+        <a:xfrm>
+          <a:off x="0" y="0"/>
+          <a:ext cx="0" cy="0"/>
+          <a:chOff x="0" y="0"/>
+          <a:chExt cx="0" cy="0"/>
+        </a:xfrm>
+      </p:grpSpPr>
       <p:sp>
         <p:nvSpPr>
           <p:cNvPr id="2" name="TextBox 1"/>
@@ -4773,6 +5248,7 @@
           <a:lstStyle/>
           <a:p>
             <a:pPr algn="ctr"/>
+            <a:endParaRPr/>
           </a:p>
         </p:txBody>
       </p:sp>
@@ -4814,7 +5290,7 @@
           </a:fontRef>
         </p:style>
         <p:txBody>
-          <a:bodyPr rtlCol="0" anchor="ctr" wrap="square" lIns="274320" rIns="274320" tIns="228600"/>
+          <a:bodyPr wrap="square" lIns="274320" tIns="228600" rIns="274320" rtlCol="0" anchor="ctr"/>
           <a:lstStyle/>
           <a:p>
             <a:pPr algn="ctr">
@@ -4825,7 +5301,16 @@
               </a:defRPr>
             </a:pPr>
             <a:r>
-              <a:t>Daftar Pustaka Akademik (APA / IEEE Standard)</a:t>
+              <a:rPr dirty="0"/>
+              <a:t>Daftar Pustaka </a:t>
+            </a:r>
+            <a:r>
+              <a:rPr dirty="0" err="1"/>
+              <a:t>Akademik</a:t>
+            </a:r>
+            <a:r>
+              <a:rPr dirty="0"/>
+              <a:t> (APA / IEEE Standard)</a:t>
             </a:r>
           </a:p>
           <a:p>
@@ -4840,7 +5325,24 @@
               </a:defRPr>
             </a:pPr>
             <a:r>
-              <a:t>[•] Wolberg, W. H., Street, W. N., &amp; Mangasarian, O. L. (1995)</a:t>
+              <a:rPr dirty="0"/>
+              <a:t>[•] </a:t>
+            </a:r>
+            <a:r>
+              <a:rPr dirty="0" err="1"/>
+              <a:t>Wolberg</a:t>
+            </a:r>
+            <a:r>
+              <a:rPr dirty="0"/>
+              <a:t>, W. H., Street, W. N., &amp; </a:t>
+            </a:r>
+            <a:r>
+              <a:rPr dirty="0" err="1"/>
+              <a:t>Mangasarian</a:t>
+            </a:r>
+            <a:r>
+              <a:rPr dirty="0"/>
+              <a:t>, O. L. (1995)</a:t>
             </a:r>
           </a:p>
           <a:p>
@@ -4855,6 +5357,7 @@
               </a:defRPr>
             </a:pPr>
             <a:r>
+              <a:rPr dirty="0"/>
               <a:t>     Breast Cancer Wisconsin (Diagnostic) Data Set. UCI Machine Learning Repository. https://doi.org/10.24432/C5DW2B</a:t>
             </a:r>
           </a:p>
@@ -4870,6 +5373,7 @@
               </a:defRPr>
             </a:pPr>
             <a:r>
+              <a:rPr dirty="0"/>
               <a:t>[•] He, K., Zhang, X., Ren, S., &amp; Sun, J. (2016)</a:t>
             </a:r>
           </a:p>
@@ -4885,6 +5389,7 @@
               </a:defRPr>
             </a:pPr>
             <a:r>
+              <a:rPr dirty="0"/>
               <a:t>     Deep Residual Learning for Image Recognition. In Proceedings of the IEEE Conference on Computer Vision and Pattern Recognition (CVPR), pp. 770-778.</a:t>
             </a:r>
           </a:p>
@@ -4900,7 +5405,32 @@
               </a:defRPr>
             </a:pPr>
             <a:r>
-              <a:t>[•] Srivastava, N., Hinton, G., Krizhevsky, A., Sutskever, I., &amp; Salakhutdinov, R. (2014)</a:t>
+              <a:rPr dirty="0"/>
+              <a:t>[•] Srivastava, N., Hinton, G., </a:t>
+            </a:r>
+            <a:r>
+              <a:rPr dirty="0" err="1"/>
+              <a:t>Krizhevsky</a:t>
+            </a:r>
+            <a:r>
+              <a:rPr dirty="0"/>
+              <a:t>, A., </a:t>
+            </a:r>
+            <a:r>
+              <a:rPr dirty="0" err="1"/>
+              <a:t>Sutskever</a:t>
+            </a:r>
+            <a:r>
+              <a:rPr dirty="0"/>
+              <a:t>, I., &amp; </a:t>
+            </a:r>
+            <a:r>
+              <a:rPr dirty="0" err="1"/>
+              <a:t>Salakhutdinov</a:t>
+            </a:r>
+            <a:r>
+              <a:rPr dirty="0"/>
+              <a:t>, R. (2014)</a:t>
             </a:r>
           </a:p>
           <a:p>
@@ -4915,6 +5445,7 @@
               </a:defRPr>
             </a:pPr>
             <a:r>
+              <a:rPr dirty="0"/>
               <a:t>     Dropout: A Simple Way to Prevent Neural Networks from Overfitting. The Journal of Machine Learning Research (JMLR), 15(1), 1929-1958.</a:t>
             </a:r>
           </a:p>
@@ -4930,7 +5461,24 @@
               </a:defRPr>
             </a:pPr>
             <a:r>
-              <a:t>[•] Ioffe, S., &amp; Szegedy, C. (2015)</a:t>
+              <a:rPr dirty="0"/>
+              <a:t>[•] </a:t>
+            </a:r>
+            <a:r>
+              <a:rPr dirty="0" err="1"/>
+              <a:t>Ioffe</a:t>
+            </a:r>
+            <a:r>
+              <a:rPr dirty="0"/>
+              <a:t>, S., &amp; </a:t>
+            </a:r>
+            <a:r>
+              <a:rPr dirty="0" err="1"/>
+              <a:t>Szegedy</a:t>
+            </a:r>
+            <a:r>
+              <a:rPr dirty="0"/>
+              <a:t>, C. (2015)</a:t>
             </a:r>
           </a:p>
           <a:p>
@@ -4945,6 +5493,7 @@
               </a:defRPr>
             </a:pPr>
             <a:r>
+              <a:rPr dirty="0"/>
               <a:t>     Batch Normalization: Accelerating Deep Network Training by Reducing Internal Covariate Shift. In International Conference on Machine Learning (ICML), pp. 448-456.</a:t>
             </a:r>
           </a:p>
@@ -4960,7 +5509,16 @@
               </a:defRPr>
             </a:pPr>
             <a:r>
-              <a:t>[•] Kingma, D. P., &amp; Ba, J. (2014)</a:t>
+              <a:rPr dirty="0"/>
+              <a:t>[•] </a:t>
+            </a:r>
+            <a:r>
+              <a:rPr dirty="0" err="1"/>
+              <a:t>Kingma</a:t>
+            </a:r>
+            <a:r>
+              <a:rPr dirty="0"/>
+              <a:t>, D. P., &amp; Ba, J. (2014)</a:t>
             </a:r>
           </a:p>
           <a:p>
@@ -4975,7 +5533,16 @@
               </a:defRPr>
             </a:pPr>
             <a:r>
-              <a:t>     Adam: A Method for Stochastic Optimization. In International Conference on Learning Representations (ICLR). arXiv preprint arXiv:1412.6980.</a:t>
+              <a:rPr dirty="0"/>
+              <a:t>     Adam: A Method for Stochastic Optimization. In International Conference on Learning Representations (ICLR). </a:t>
+            </a:r>
+            <a:r>
+              <a:rPr dirty="0" err="1"/>
+              <a:t>arXiv</a:t>
+            </a:r>
+            <a:r>
+              <a:rPr dirty="0"/>
+              <a:t> preprint arXiv:1412.6980.</a:t>
             </a:r>
           </a:p>
           <a:p>
@@ -4990,7 +5557,40 @@
               </a:defRPr>
             </a:pPr>
             <a:r>
-              <a:t>[•] Gorishniy, Y., Rubachev, I., Khrulkov, V., &amp; Babenko, A. (2021)</a:t>
+              <a:rPr dirty="0"/>
+              <a:t>[•] </a:t>
+            </a:r>
+            <a:r>
+              <a:rPr dirty="0" err="1"/>
+              <a:t>Gorishniy</a:t>
+            </a:r>
+            <a:r>
+              <a:rPr dirty="0"/>
+              <a:t>, Y., </a:t>
+            </a:r>
+            <a:r>
+              <a:rPr dirty="0" err="1"/>
+              <a:t>Rubachev</a:t>
+            </a:r>
+            <a:r>
+              <a:rPr dirty="0"/>
+              <a:t>, I., </a:t>
+            </a:r>
+            <a:r>
+              <a:rPr dirty="0" err="1"/>
+              <a:t>Khrulkov</a:t>
+            </a:r>
+            <a:r>
+              <a:rPr dirty="0"/>
+              <a:t>, V., &amp; </a:t>
+            </a:r>
+            <a:r>
+              <a:rPr dirty="0" err="1"/>
+              <a:t>Babenko</a:t>
+            </a:r>
+            <a:r>
+              <a:rPr dirty="0"/>
+              <a:t>, A. (2021)</a:t>
             </a:r>
           </a:p>
           <a:p>
@@ -5005,7 +5605,19 @@
               </a:defRPr>
             </a:pPr>
             <a:r>
-              <a:t>     Revisiting Deep Learning Models for Tabular Data. Advances in Neural Information Processing Systems (NeurIPS), 34, 18932-18943.</a:t>
+              <a:t>     Revisiting Deep Learning Models for Tabular Data. </a:t>
+            </a:r>
+            <a:r>
+              <a:rPr dirty="0"/>
+              <a:t>Advances in Neural Information Processing Systems (</a:t>
+            </a:r>
+            <a:r>
+              <a:rPr dirty="0" err="1"/>
+              <a:t>NeurIPS</a:t>
+            </a:r>
+            <a:r>
+              <a:rPr dirty="0"/>
+              <a:t>), 34, 18932-18943.</a:t>
             </a:r>
           </a:p>
           <a:p>
@@ -5020,7 +5632,16 @@
               </a:defRPr>
             </a:pPr>
             <a:r>
-              <a:t>[•] Chicco, D., &amp; Jurman, G. (2020)</a:t>
+              <a:rPr dirty="0"/>
+              <a:t>[•] Chicco, D., &amp; </a:t>
+            </a:r>
+            <a:r>
+              <a:rPr dirty="0" err="1"/>
+              <a:t>Jurman</a:t>
+            </a:r>
+            <a:r>
+              <a:rPr dirty="0"/>
+              <a:t>, G. (2020)</a:t>
             </a:r>
           </a:p>
           <a:p>
@@ -5035,6 +5656,7 @@
               </a:defRPr>
             </a:pPr>
             <a:r>
+              <a:rPr dirty="0"/>
               <a:t>     The Advantages of the Matthews Correlation Coefficient (MCC) over F1 score and Accuracy in Binary Assessment Evaluation. BMC Genomics, 21(1), 1-13.</a:t>
             </a:r>
           </a:p>
@@ -5049,7 +5671,7 @@
 </file>
 
 <file path=ppt/slides/slide2.xml><?xml version="1.0" encoding="utf-8"?>
-<p:sld xmlns:a="http://schemas.openxmlformats.org/drawingml/2006/main" xmlns:p="http://schemas.openxmlformats.org/presentationml/2006/main" xmlns:r="http://schemas.openxmlformats.org/officeDocument/2006/relationships">
+<p:sld xmlns:a="http://schemas.openxmlformats.org/drawingml/2006/main" xmlns:r="http://schemas.openxmlformats.org/officeDocument/2006/relationships" xmlns:p="http://schemas.openxmlformats.org/presentationml/2006/main">
   <p:cSld>
     <p:spTree>
       <p:nvGrpSpPr>
@@ -5057,7 +5679,14 @@
         <p:cNvGrpSpPr/>
         <p:nvPr/>
       </p:nvGrpSpPr>
-      <p:grpSpPr/>
+      <p:grpSpPr>
+        <a:xfrm>
+          <a:off x="0" y="0"/>
+          <a:ext cx="0" cy="0"/>
+          <a:chOff x="0" y="0"/>
+          <a:chExt cx="0" cy="0"/>
+        </a:xfrm>
+      </p:grpSpPr>
       <p:sp>
         <p:nvSpPr>
           <p:cNvPr id="2" name="TextBox 1"/>
@@ -5202,6 +5831,7 @@
           <a:lstStyle/>
           <a:p>
             <a:pPr algn="ctr"/>
+            <a:endParaRPr/>
           </a:p>
         </p:txBody>
       </p:sp>
@@ -5243,7 +5873,7 @@
           </a:fontRef>
         </p:style>
         <p:txBody>
-          <a:bodyPr rtlCol="0" anchor="ctr" wrap="square" lIns="146304" rIns="146304" tIns="182880"/>
+          <a:bodyPr wrap="square" lIns="146304" tIns="182880" rIns="146304" rtlCol="0" anchor="ctr"/>
           <a:lstStyle/>
           <a:p>
             <a:pPr algn="ctr">
@@ -5387,7 +6017,7 @@
           </a:fontRef>
         </p:style>
         <p:txBody>
-          <a:bodyPr rtlCol="0" anchor="ctr" wrap="square" lIns="146304" rIns="146304" tIns="182880"/>
+          <a:bodyPr wrap="square" lIns="146304" tIns="182880" rIns="146304" rtlCol="0" anchor="ctr"/>
           <a:lstStyle/>
           <a:p>
             <a:pPr algn="ctr">
@@ -5531,7 +6161,7 @@
           </a:fontRef>
         </p:style>
         <p:txBody>
-          <a:bodyPr rtlCol="0" anchor="ctr" wrap="square" lIns="146304" rIns="146304" tIns="182880"/>
+          <a:bodyPr wrap="square" lIns="146304" tIns="182880" rIns="146304" rtlCol="0" anchor="ctr"/>
           <a:lstStyle/>
           <a:p>
             <a:pPr algn="ctr">
@@ -5675,7 +6305,7 @@
           </a:fontRef>
         </p:style>
         <p:txBody>
-          <a:bodyPr rtlCol="0" anchor="ctr" wrap="square" lIns="146304" rIns="146304" tIns="182880"/>
+          <a:bodyPr wrap="square" lIns="146304" tIns="182880" rIns="146304" rtlCol="0" anchor="ctr"/>
           <a:lstStyle/>
           <a:p>
             <a:pPr algn="ctr">
@@ -5790,7 +6420,7 @@
 </file>
 
 <file path=ppt/slides/slide3.xml><?xml version="1.0" encoding="utf-8"?>
-<p:sld xmlns:a="http://schemas.openxmlformats.org/drawingml/2006/main" xmlns:p="http://schemas.openxmlformats.org/presentationml/2006/main" xmlns:r="http://schemas.openxmlformats.org/officeDocument/2006/relationships">
+<p:sld xmlns:a="http://schemas.openxmlformats.org/drawingml/2006/main" xmlns:r="http://schemas.openxmlformats.org/officeDocument/2006/relationships" xmlns:p="http://schemas.openxmlformats.org/presentationml/2006/main">
   <p:cSld>
     <p:spTree>
       <p:nvGrpSpPr>
@@ -5798,7 +6428,14 @@
         <p:cNvGrpSpPr/>
         <p:nvPr/>
       </p:nvGrpSpPr>
-      <p:grpSpPr/>
+      <p:grpSpPr>
+        <a:xfrm>
+          <a:off x="0" y="0"/>
+          <a:ext cx="0" cy="0"/>
+          <a:chOff x="0" y="0"/>
+          <a:chExt cx="0" cy="0"/>
+        </a:xfrm>
+      </p:grpSpPr>
       <p:sp>
         <p:nvSpPr>
           <p:cNvPr id="2" name="TextBox 1"/>
@@ -5943,6 +6580,7 @@
           <a:lstStyle/>
           <a:p>
             <a:pPr algn="ctr"/>
+            <a:endParaRPr/>
           </a:p>
         </p:txBody>
       </p:sp>
@@ -5984,7 +6622,7 @@
           </a:fontRef>
         </p:style>
         <p:txBody>
-          <a:bodyPr rtlCol="0" anchor="ctr" wrap="square" lIns="228600" rIns="228600" tIns="228600"/>
+          <a:bodyPr wrap="square" lIns="228600" tIns="228600" rIns="228600" rtlCol="0" anchor="ctr"/>
           <a:lstStyle/>
           <a:p>
             <a:pPr algn="ctr">
@@ -6128,7 +6766,7 @@
           </a:fontRef>
         </p:style>
         <p:txBody>
-          <a:bodyPr rtlCol="0" anchor="ctr" wrap="square" lIns="228600" rIns="228600" tIns="228600"/>
+          <a:bodyPr wrap="square" lIns="228600" tIns="228600" rIns="228600" rtlCol="0" anchor="ctr"/>
           <a:lstStyle/>
           <a:p>
             <a:pPr algn="ctr">
@@ -6251,7 +6889,7 @@
 </file>
 
 <file path=ppt/slides/slide4.xml><?xml version="1.0" encoding="utf-8"?>
-<p:sld xmlns:a="http://schemas.openxmlformats.org/drawingml/2006/main" xmlns:p="http://schemas.openxmlformats.org/presentationml/2006/main" xmlns:r="http://schemas.openxmlformats.org/officeDocument/2006/relationships">
+<p:sld xmlns:a="http://schemas.openxmlformats.org/drawingml/2006/main" xmlns:r="http://schemas.openxmlformats.org/officeDocument/2006/relationships" xmlns:p="http://schemas.openxmlformats.org/presentationml/2006/main">
   <p:cSld>
     <p:spTree>
       <p:nvGrpSpPr>
@@ -6259,7 +6897,14 @@
         <p:cNvGrpSpPr/>
         <p:nvPr/>
       </p:nvGrpSpPr>
-      <p:grpSpPr/>
+      <p:grpSpPr>
+        <a:xfrm>
+          <a:off x="0" y="0"/>
+          <a:ext cx="0" cy="0"/>
+          <a:chOff x="0" y="0"/>
+          <a:chExt cx="0" cy="0"/>
+        </a:xfrm>
+      </p:grpSpPr>
       <p:sp>
         <p:nvSpPr>
           <p:cNvPr id="2" name="TextBox 1"/>
@@ -6404,6 +7049,7 @@
           <a:lstStyle/>
           <a:p>
             <a:pPr algn="ctr"/>
+            <a:endParaRPr/>
           </a:p>
         </p:txBody>
       </p:sp>
@@ -6445,7 +7091,7 @@
           </a:fontRef>
         </p:style>
         <p:txBody>
-          <a:bodyPr rtlCol="0" anchor="ctr" wrap="square" lIns="228600" rIns="228600" tIns="228600"/>
+          <a:bodyPr wrap="square" lIns="228600" tIns="228600" rIns="228600" rtlCol="0" anchor="ctr"/>
           <a:lstStyle/>
           <a:p>
             <a:pPr algn="ctr">
@@ -6599,7 +7245,7 @@
 </file>
 
 <file path=ppt/slides/slide5.xml><?xml version="1.0" encoding="utf-8"?>
-<p:sld xmlns:a="http://schemas.openxmlformats.org/drawingml/2006/main" xmlns:p="http://schemas.openxmlformats.org/presentationml/2006/main" xmlns:r="http://schemas.openxmlformats.org/officeDocument/2006/relationships">
+<p:sld xmlns:a="http://schemas.openxmlformats.org/drawingml/2006/main" xmlns:r="http://schemas.openxmlformats.org/officeDocument/2006/relationships" xmlns:p="http://schemas.openxmlformats.org/presentationml/2006/main">
   <p:cSld>
     <p:spTree>
       <p:nvGrpSpPr>
@@ -6607,7 +7253,14 @@
         <p:cNvGrpSpPr/>
         <p:nvPr/>
       </p:nvGrpSpPr>
-      <p:grpSpPr/>
+      <p:grpSpPr>
+        <a:xfrm>
+          <a:off x="0" y="0"/>
+          <a:ext cx="0" cy="0"/>
+          <a:chOff x="0" y="0"/>
+          <a:chExt cx="0" cy="0"/>
+        </a:xfrm>
+      </p:grpSpPr>
       <p:sp>
         <p:nvSpPr>
           <p:cNvPr id="2" name="TextBox 1"/>
@@ -6752,6 +7405,7 @@
           <a:lstStyle/>
           <a:p>
             <a:pPr algn="ctr"/>
+            <a:endParaRPr/>
           </a:p>
         </p:txBody>
       </p:sp>
@@ -6817,7 +7471,7 @@
           </a:fontRef>
         </p:style>
         <p:txBody>
-          <a:bodyPr rtlCol="0" anchor="ctr" wrap="square" lIns="137160" rIns="137160" tIns="109728"/>
+          <a:bodyPr wrap="square" lIns="137160" tIns="109728" rIns="137160" rtlCol="0" anchor="ctr"/>
           <a:lstStyle/>
           <a:p>
             <a:pPr algn="ctr">
@@ -6910,7 +7564,7 @@
           </a:fontRef>
         </p:style>
         <p:txBody>
-          <a:bodyPr rtlCol="0" anchor="ctr" wrap="square" lIns="137160" rIns="137160" tIns="109728"/>
+          <a:bodyPr wrap="square" lIns="137160" tIns="109728" rIns="137160" rtlCol="0" anchor="ctr"/>
           <a:lstStyle/>
           <a:p>
             <a:pPr algn="ctr">
@@ -7003,7 +7657,7 @@
           </a:fontRef>
         </p:style>
         <p:txBody>
-          <a:bodyPr rtlCol="0" anchor="ctr" wrap="square" lIns="137160" rIns="137160" tIns="109728"/>
+          <a:bodyPr wrap="square" lIns="137160" tIns="109728" rIns="137160" rtlCol="0" anchor="ctr"/>
           <a:lstStyle/>
           <a:p>
             <a:pPr algn="ctr">
@@ -7096,7 +7750,7 @@
           </a:fontRef>
         </p:style>
         <p:txBody>
-          <a:bodyPr rtlCol="0" anchor="ctr" wrap="square" lIns="137160" rIns="137160" tIns="109728"/>
+          <a:bodyPr wrap="square" lIns="137160" tIns="109728" rIns="137160" rtlCol="0" anchor="ctr"/>
           <a:lstStyle/>
           <a:p>
             <a:pPr algn="ctr">
@@ -7160,7 +7814,7 @@
 </file>
 
 <file path=ppt/slides/slide6.xml><?xml version="1.0" encoding="utf-8"?>
-<p:sld xmlns:a="http://schemas.openxmlformats.org/drawingml/2006/main" xmlns:p="http://schemas.openxmlformats.org/presentationml/2006/main" xmlns:r="http://schemas.openxmlformats.org/officeDocument/2006/relationships">
+<p:sld xmlns:a="http://schemas.openxmlformats.org/drawingml/2006/main" xmlns:r="http://schemas.openxmlformats.org/officeDocument/2006/relationships" xmlns:p="http://schemas.openxmlformats.org/presentationml/2006/main">
   <p:cSld>
     <p:spTree>
       <p:nvGrpSpPr>
@@ -7168,7 +7822,14 @@
         <p:cNvGrpSpPr/>
         <p:nvPr/>
       </p:nvGrpSpPr>
-      <p:grpSpPr/>
+      <p:grpSpPr>
+        <a:xfrm>
+          <a:off x="0" y="0"/>
+          <a:ext cx="0" cy="0"/>
+          <a:chOff x="0" y="0"/>
+          <a:chExt cx="0" cy="0"/>
+        </a:xfrm>
+      </p:grpSpPr>
       <p:sp>
         <p:nvSpPr>
           <p:cNvPr id="2" name="TextBox 1"/>
@@ -7313,6 +7974,7 @@
           <a:lstStyle/>
           <a:p>
             <a:pPr algn="ctr"/>
+            <a:endParaRPr/>
           </a:p>
         </p:txBody>
       </p:sp>
@@ -7354,7 +8016,7 @@
           </a:fontRef>
         </p:style>
         <p:txBody>
-          <a:bodyPr rtlCol="0" anchor="ctr" wrap="square" lIns="228600" rIns="228600" tIns="182880"/>
+          <a:bodyPr wrap="square" lIns="228600" tIns="182880" rIns="228600" rtlCol="0" anchor="ctr"/>
           <a:lstStyle/>
           <a:p>
             <a:pPr algn="ctr">
@@ -7583,7 +8245,7 @@
 </file>
 
 <file path=ppt/slides/slide7.xml><?xml version="1.0" encoding="utf-8"?>
-<p:sld xmlns:a="http://schemas.openxmlformats.org/drawingml/2006/main" xmlns:p="http://schemas.openxmlformats.org/presentationml/2006/main" xmlns:r="http://schemas.openxmlformats.org/officeDocument/2006/relationships">
+<p:sld xmlns:a="http://schemas.openxmlformats.org/drawingml/2006/main" xmlns:r="http://schemas.openxmlformats.org/officeDocument/2006/relationships" xmlns:p="http://schemas.openxmlformats.org/presentationml/2006/main">
   <p:cSld>
     <p:spTree>
       <p:nvGrpSpPr>
@@ -7591,7 +8253,14 @@
         <p:cNvGrpSpPr/>
         <p:nvPr/>
       </p:nvGrpSpPr>
-      <p:grpSpPr/>
+      <p:grpSpPr>
+        <a:xfrm>
+          <a:off x="0" y="0"/>
+          <a:ext cx="0" cy="0"/>
+          <a:chOff x="0" y="0"/>
+          <a:chExt cx="0" cy="0"/>
+        </a:xfrm>
+      </p:grpSpPr>
       <p:sp>
         <p:nvSpPr>
           <p:cNvPr id="2" name="TextBox 1"/>
@@ -7736,6 +8405,7 @@
           <a:lstStyle/>
           <a:p>
             <a:pPr algn="ctr"/>
+            <a:endParaRPr/>
           </a:p>
         </p:txBody>
       </p:sp>
@@ -7801,7 +8471,7 @@
           </a:fontRef>
         </p:style>
         <p:txBody>
-          <a:bodyPr rtlCol="0" anchor="ctr" wrap="square" lIns="182880" rIns="182880" tIns="182880"/>
+          <a:bodyPr wrap="square" lIns="182880" tIns="182880" rIns="182880" rtlCol="0" anchor="ctr"/>
           <a:lstStyle/>
           <a:p>
             <a:pPr algn="ctr">
@@ -7836,11 +8506,41 @@
                 <a:tableStyleId>{5C22544A-7EE6-4342-B048-85BDC9FD1C3A}</a:tableStyleId>
               </a:tblPr>
               <a:tblGrid>
-                <a:gridCol w="1280160"/>
-                <a:gridCol w="822960"/>
-                <a:gridCol w="822960"/>
-                <a:gridCol w="822960"/>
-                <a:gridCol w="822960"/>
+                <a:gridCol w="1280160">
+                  <a:extLst>
+                    <a:ext uri="{9D8B030D-6E8A-4147-A177-3AD203B41FA5}">
+                      <a16:colId xmlns:a16="http://schemas.microsoft.com/office/drawing/2014/main" val="20000"/>
+                    </a:ext>
+                  </a:extLst>
+                </a:gridCol>
+                <a:gridCol w="822960">
+                  <a:extLst>
+                    <a:ext uri="{9D8B030D-6E8A-4147-A177-3AD203B41FA5}">
+                      <a16:colId xmlns:a16="http://schemas.microsoft.com/office/drawing/2014/main" val="20001"/>
+                    </a:ext>
+                  </a:extLst>
+                </a:gridCol>
+                <a:gridCol w="822960">
+                  <a:extLst>
+                    <a:ext uri="{9D8B030D-6E8A-4147-A177-3AD203B41FA5}">
+                      <a16:colId xmlns:a16="http://schemas.microsoft.com/office/drawing/2014/main" val="20002"/>
+                    </a:ext>
+                  </a:extLst>
+                </a:gridCol>
+                <a:gridCol w="822960">
+                  <a:extLst>
+                    <a:ext uri="{9D8B030D-6E8A-4147-A177-3AD203B41FA5}">
+                      <a16:colId xmlns:a16="http://schemas.microsoft.com/office/drawing/2014/main" val="20003"/>
+                    </a:ext>
+                  </a:extLst>
+                </a:gridCol>
+                <a:gridCol w="822960">
+                  <a:extLst>
+                    <a:ext uri="{9D8B030D-6E8A-4147-A177-3AD203B41FA5}">
+                      <a16:colId xmlns:a16="http://schemas.microsoft.com/office/drawing/2014/main" val="20004"/>
+                    </a:ext>
+                  </a:extLst>
+                </a:gridCol>
               </a:tblGrid>
               <a:tr h="420624">
                 <a:tc>
@@ -7958,6 +8658,11 @@
                     </a:solidFill>
                   </a:tcPr>
                 </a:tc>
+                <a:extLst>
+                  <a:ext uri="{0D108BD9-81ED-4DB2-BD59-A6C34878D82A}">
+                    <a16:rowId xmlns:a16="http://schemas.microsoft.com/office/drawing/2014/main" val="10000"/>
+                  </a:ext>
+                </a:extLst>
               </a:tr>
               <a:tr h="420624">
                 <a:tc>
@@ -8075,6 +8780,11 @@
                     </a:solidFill>
                   </a:tcPr>
                 </a:tc>
+                <a:extLst>
+                  <a:ext uri="{0D108BD9-81ED-4DB2-BD59-A6C34878D82A}">
+                    <a16:rowId xmlns:a16="http://schemas.microsoft.com/office/drawing/2014/main" val="10001"/>
+                  </a:ext>
+                </a:extLst>
               </a:tr>
               <a:tr h="420624">
                 <a:tc>
@@ -8192,6 +8902,11 @@
                     </a:solidFill>
                   </a:tcPr>
                 </a:tc>
+                <a:extLst>
+                  <a:ext uri="{0D108BD9-81ED-4DB2-BD59-A6C34878D82A}">
+                    <a16:rowId xmlns:a16="http://schemas.microsoft.com/office/drawing/2014/main" val="10002"/>
+                  </a:ext>
+                </a:extLst>
               </a:tr>
               <a:tr h="420624">
                 <a:tc>
@@ -8309,6 +9024,11 @@
                     </a:solidFill>
                   </a:tcPr>
                 </a:tc>
+                <a:extLst>
+                  <a:ext uri="{0D108BD9-81ED-4DB2-BD59-A6C34878D82A}">
+                    <a16:rowId xmlns:a16="http://schemas.microsoft.com/office/drawing/2014/main" val="10003"/>
+                  </a:ext>
+                </a:extLst>
               </a:tr>
               <a:tr h="420624">
                 <a:tc>
@@ -8426,6 +9146,11 @@
                     </a:solidFill>
                   </a:tcPr>
                 </a:tc>
+                <a:extLst>
+                  <a:ext uri="{0D108BD9-81ED-4DB2-BD59-A6C34878D82A}">
+                    <a16:rowId xmlns:a16="http://schemas.microsoft.com/office/drawing/2014/main" val="10004"/>
+                  </a:ext>
+                </a:extLst>
               </a:tr>
             </a:tbl>
           </a:graphicData>
@@ -8520,7 +9245,7 @@
 </file>
 
 <file path=ppt/slides/slide8.xml><?xml version="1.0" encoding="utf-8"?>
-<p:sld xmlns:a="http://schemas.openxmlformats.org/drawingml/2006/main" xmlns:p="http://schemas.openxmlformats.org/presentationml/2006/main" xmlns:r="http://schemas.openxmlformats.org/officeDocument/2006/relationships">
+<p:sld xmlns:a="http://schemas.openxmlformats.org/drawingml/2006/main" xmlns:r="http://schemas.openxmlformats.org/officeDocument/2006/relationships" xmlns:p="http://schemas.openxmlformats.org/presentationml/2006/main">
   <p:cSld>
     <p:spTree>
       <p:nvGrpSpPr>
@@ -8528,7 +9253,14 @@
         <p:cNvGrpSpPr/>
         <p:nvPr/>
       </p:nvGrpSpPr>
-      <p:grpSpPr/>
+      <p:grpSpPr>
+        <a:xfrm>
+          <a:off x="0" y="0"/>
+          <a:ext cx="0" cy="0"/>
+          <a:chOff x="0" y="0"/>
+          <a:chExt cx="0" cy="0"/>
+        </a:xfrm>
+      </p:grpSpPr>
       <p:sp>
         <p:nvSpPr>
           <p:cNvPr id="2" name="TextBox 1"/>
@@ -8673,6 +9405,7 @@
           <a:lstStyle/>
           <a:p>
             <a:pPr algn="ctr"/>
+            <a:endParaRPr/>
           </a:p>
         </p:txBody>
       </p:sp>
@@ -8738,7 +9471,7 @@
           </a:fontRef>
         </p:style>
         <p:txBody>
-          <a:bodyPr rtlCol="0" anchor="ctr" wrap="square" lIns="182880" rIns="182880" tIns="182880"/>
+          <a:bodyPr wrap="square" lIns="182880" tIns="182880" rIns="182880" rtlCol="0" anchor="ctr"/>
           <a:lstStyle/>
           <a:p>
             <a:pPr algn="ctr">
@@ -8883,7 +9616,7 @@
 </file>
 
 <file path=ppt/slides/slide9.xml><?xml version="1.0" encoding="utf-8"?>
-<p:sld xmlns:a="http://schemas.openxmlformats.org/drawingml/2006/main" xmlns:p="http://schemas.openxmlformats.org/presentationml/2006/main" xmlns:r="http://schemas.openxmlformats.org/officeDocument/2006/relationships">
+<p:sld xmlns:a="http://schemas.openxmlformats.org/drawingml/2006/main" xmlns:r="http://schemas.openxmlformats.org/officeDocument/2006/relationships" xmlns:p="http://schemas.openxmlformats.org/presentationml/2006/main">
   <p:cSld>
     <p:spTree>
       <p:nvGrpSpPr>
@@ -8891,7 +9624,14 @@
         <p:cNvGrpSpPr/>
         <p:nvPr/>
       </p:nvGrpSpPr>
-      <p:grpSpPr/>
+      <p:grpSpPr>
+        <a:xfrm>
+          <a:off x="0" y="0"/>
+          <a:ext cx="0" cy="0"/>
+          <a:chOff x="0" y="0"/>
+          <a:chExt cx="0" cy="0"/>
+        </a:xfrm>
+      </p:grpSpPr>
       <p:sp>
         <p:nvSpPr>
           <p:cNvPr id="2" name="TextBox 1"/>
@@ -9036,6 +9776,7 @@
           <a:lstStyle/>
           <a:p>
             <a:pPr algn="ctr"/>
+            <a:endParaRPr/>
           </a:p>
         </p:txBody>
       </p:sp>
@@ -9125,7 +9866,7 @@
           </a:fontRef>
         </p:style>
         <p:txBody>
-          <a:bodyPr rtlCol="0" anchor="ctr" wrap="square" lIns="182880" rIns="182880" tIns="137160"/>
+          <a:bodyPr wrap="square" lIns="182880" tIns="137160" rIns="182880" rtlCol="0" anchor="ctr"/>
           <a:lstStyle/>
           <a:p>
             <a:pPr algn="ctr">

</xml_diff>

<commit_message>
Add presentation speech script PDF: Naskah_Presentasi_PMML.pdf
</commit_message>
<xml_diff>
--- a/PMML_Mini_Project_Presentation.pptx
+++ b/PMML_Mini_Project_Presentation.pptx
@@ -5605,11 +5605,8 @@
               </a:defRPr>
             </a:pPr>
             <a:r>
-              <a:t>     Revisiting Deep Learning Models for Tabular Data. </a:t>
-            </a:r>
-            <a:r>
-              <a:rPr dirty="0"/>
-              <a:t>Advances in Neural Information Processing Systems (</a:t>
+              <a:rPr dirty="0"/>
+              <a:t>     Revisiting Deep Learning Models for Tabular Data. Advances in Neural Information Processing Systems (</a:t>
             </a:r>
             <a:r>
               <a:rPr dirty="0" err="1"/>

</xml_diff>